<commit_message>
Major PPT quality upgrade: rebuild all 144 presentations with rich slide types
- Slide engine: 9 slide types (title, section, content, key terms, two-column,
  table, worked example, check understanding, end)
- Design: navy/teal/gold palette, grade-specific accents, Georgia headings,
  accent bars, divider lines
- Content: key vocabulary cards with definitions, comparison columns,
  data tables with colour-coded headers, numbered worked examples,
  check-your-understanding checklists
- Coverage: G6 Maths (30), G6 Science (30), G7 Maths (30),
  G7 Science (30), G8 Science (24)
- Removed 36 unreferenced legacy PPT files (old naming conventions)
</commit_message>
<xml_diff>
--- a/static/ppts/G6_Math_T1_Full_Revision.pptx
+++ b/static/ppts/G6_Math_T1_Full_Revision.pptx
@@ -12,12 +12,15 @@
     <p:sldId id="260" r:id="rId6"/>
     <p:sldId id="261" r:id="rId7"/>
     <p:sldId id="262" r:id="rId8"/>
+    <p:sldId id="263" r:id="rId9"/>
+    <p:sldId id="264" r:id="rId10"/>
+    <p:sldId id="265" r:id="rId11"/>
   </p:sldIdLst>
   <p:notesMasterIdLst>
-    <p:notesMasterId r:id="rId9"/>
+    <p:notesMasterId r:id="rId12"/>
   </p:notesMasterIdLst>
-  <p:sldSz cx="9144000" cy="5143500"/>
-  <p:notesSz cx="5143500" cy="9144000"/>
+  <p:sldSz cx="12192000" cy="6858000"/>
+  <p:notesSz cx="6858000" cy="12192000"/>
   <p:defaultTextStyle>
     <a:lvl1pPr marL="0" algn="l" defTabSz="914400" rtl="0" eaLnBrk="1" latinLnBrk="0" hangingPunct="1">
       <a:defRPr sz="1800" kern="1200">
@@ -550,6 +553,94 @@
 </p:notes>
 </file>
 
+<file path=ppt/notesSlides/notesSlide10.xml><?xml version="1.0" encoding="utf-8"?>
+<p:notes xmlns:a="http://schemas.openxmlformats.org/drawingml/2006/main" xmlns:r="http://schemas.openxmlformats.org/officeDocument/2006/relationships" xmlns:p="http://schemas.openxmlformats.org/presentationml/2006/main">
+  <p:cSld>
+    <p:spTree>
+      <p:nvGrpSpPr>
+        <p:cNvPr id="1" name=""/>
+        <p:cNvGrpSpPr/>
+        <p:nvPr/>
+      </p:nvGrpSpPr>
+      <p:grpSpPr>
+        <a:xfrm>
+          <a:off x="0" y="0"/>
+          <a:ext cx="0" cy="0"/>
+          <a:chOff x="0" y="0"/>
+          <a:chExt cx="0" cy="0"/>
+        </a:xfrm>
+      </p:grpSpPr>
+      <p:sp>
+        <p:nvSpPr>
+          <p:cNvPr id="2" name="Slide Image Placeholder 1"/>
+          <p:cNvSpPr>
+            <a:spLocks noGrp="1" noRot="1" noChangeAspect="1"/>
+          </p:cNvSpPr>
+          <p:nvPr>
+            <p:ph type="sldImg"/>
+          </p:nvPr>
+        </p:nvSpPr>
+        <p:spPr/>
+      </p:sp>
+      <p:sp>
+        <p:nvSpPr>
+          <p:cNvPr id="3" name="Notes Placeholder 2"/>
+          <p:cNvSpPr>
+            <a:spLocks noGrp="1"/>
+          </p:cNvSpPr>
+          <p:nvPr>
+            <p:ph type="body" idx="1"/>
+          </p:nvPr>
+        </p:nvSpPr>
+        <p:spPr/>
+        <p:txBody>
+          <a:bodyPr/>
+          <a:lstStyle/>
+          <a:p>
+            <a:r>
+              <a:rPr lang="en-US" dirty="0"/>
+              <a:t/>
+            </a:r>
+            <a:endParaRPr lang="en-US" dirty="0"/>
+          </a:p>
+        </p:txBody>
+      </p:sp>
+      <p:sp>
+        <p:nvSpPr>
+          <p:cNvPr id="4" name="Slide Number Placeholder 3"/>
+          <p:cNvSpPr>
+            <a:spLocks noGrp="1"/>
+          </p:cNvSpPr>
+          <p:nvPr>
+            <p:ph type="sldNum" sz="quarter" idx="10"/>
+          </p:nvPr>
+        </p:nvSpPr>
+        <p:spPr/>
+        <p:txBody>
+          <a:bodyPr/>
+          <a:lstStyle/>
+          <a:p>
+            <a:fld id="{F7021451-1387-4CA6-816F-3879F97B5CBC}" type="slidenum">
+              <a:rPr lang="en-US"/>
+              <a:t>10</a:t>
+            </a:fld>
+            <a:endParaRPr lang="en-US"/>
+          </a:p>
+        </p:txBody>
+      </p:sp>
+    </p:spTree>
+    <p:extLst>
+      <p:ext uri="{BB962C8B-B14F-4D97-AF65-F5344CB8AC3E}">
+        <p14:creationId xmlns:p14="http://schemas.microsoft.com/office/powerpoint/2010/main" val="1024086991"/>
+      </p:ext>
+    </p:extLst>
+  </p:cSld>
+  <p:clrMapOvr>
+    <a:masterClrMapping/>
+  </p:clrMapOvr>
+</p:notes>
+</file>
+
 <file path=ppt/notesSlides/notesSlide2.xml><?xml version="1.0" encoding="utf-8"?>
 <p:notes xmlns:a="http://schemas.openxmlformats.org/drawingml/2006/main" xmlns:r="http://schemas.openxmlformats.org/officeDocument/2006/relationships" xmlns:p="http://schemas.openxmlformats.org/presentationml/2006/main">
   <p:cSld>
@@ -1060,6 +1151,182 @@
             <a:fld id="{F7021451-1387-4CA6-816F-3879F97B5CBC}" type="slidenum">
               <a:rPr lang="en-US"/>
               <a:t>7</a:t>
+            </a:fld>
+            <a:endParaRPr lang="en-US"/>
+          </a:p>
+        </p:txBody>
+      </p:sp>
+    </p:spTree>
+    <p:extLst>
+      <p:ext uri="{BB962C8B-B14F-4D97-AF65-F5344CB8AC3E}">
+        <p14:creationId xmlns:p14="http://schemas.microsoft.com/office/powerpoint/2010/main" val="1024086991"/>
+      </p:ext>
+    </p:extLst>
+  </p:cSld>
+  <p:clrMapOvr>
+    <a:masterClrMapping/>
+  </p:clrMapOvr>
+</p:notes>
+</file>
+
+<file path=ppt/notesSlides/notesSlide8.xml><?xml version="1.0" encoding="utf-8"?>
+<p:notes xmlns:a="http://schemas.openxmlformats.org/drawingml/2006/main" xmlns:r="http://schemas.openxmlformats.org/officeDocument/2006/relationships" xmlns:p="http://schemas.openxmlformats.org/presentationml/2006/main">
+  <p:cSld>
+    <p:spTree>
+      <p:nvGrpSpPr>
+        <p:cNvPr id="1" name=""/>
+        <p:cNvGrpSpPr/>
+        <p:nvPr/>
+      </p:nvGrpSpPr>
+      <p:grpSpPr>
+        <a:xfrm>
+          <a:off x="0" y="0"/>
+          <a:ext cx="0" cy="0"/>
+          <a:chOff x="0" y="0"/>
+          <a:chExt cx="0" cy="0"/>
+        </a:xfrm>
+      </p:grpSpPr>
+      <p:sp>
+        <p:nvSpPr>
+          <p:cNvPr id="2" name="Slide Image Placeholder 1"/>
+          <p:cNvSpPr>
+            <a:spLocks noGrp="1" noRot="1" noChangeAspect="1"/>
+          </p:cNvSpPr>
+          <p:nvPr>
+            <p:ph type="sldImg"/>
+          </p:nvPr>
+        </p:nvSpPr>
+        <p:spPr/>
+      </p:sp>
+      <p:sp>
+        <p:nvSpPr>
+          <p:cNvPr id="3" name="Notes Placeholder 2"/>
+          <p:cNvSpPr>
+            <a:spLocks noGrp="1"/>
+          </p:cNvSpPr>
+          <p:nvPr>
+            <p:ph type="body" idx="1"/>
+          </p:nvPr>
+        </p:nvSpPr>
+        <p:spPr/>
+        <p:txBody>
+          <a:bodyPr/>
+          <a:lstStyle/>
+          <a:p>
+            <a:r>
+              <a:rPr lang="en-US" dirty="0"/>
+              <a:t/>
+            </a:r>
+            <a:endParaRPr lang="en-US" dirty="0"/>
+          </a:p>
+        </p:txBody>
+      </p:sp>
+      <p:sp>
+        <p:nvSpPr>
+          <p:cNvPr id="4" name="Slide Number Placeholder 3"/>
+          <p:cNvSpPr>
+            <a:spLocks noGrp="1"/>
+          </p:cNvSpPr>
+          <p:nvPr>
+            <p:ph type="sldNum" sz="quarter" idx="10"/>
+          </p:nvPr>
+        </p:nvSpPr>
+        <p:spPr/>
+        <p:txBody>
+          <a:bodyPr/>
+          <a:lstStyle/>
+          <a:p>
+            <a:fld id="{F7021451-1387-4CA6-816F-3879F97B5CBC}" type="slidenum">
+              <a:rPr lang="en-US"/>
+              <a:t>8</a:t>
+            </a:fld>
+            <a:endParaRPr lang="en-US"/>
+          </a:p>
+        </p:txBody>
+      </p:sp>
+    </p:spTree>
+    <p:extLst>
+      <p:ext uri="{BB962C8B-B14F-4D97-AF65-F5344CB8AC3E}">
+        <p14:creationId xmlns:p14="http://schemas.microsoft.com/office/powerpoint/2010/main" val="1024086991"/>
+      </p:ext>
+    </p:extLst>
+  </p:cSld>
+  <p:clrMapOvr>
+    <a:masterClrMapping/>
+  </p:clrMapOvr>
+</p:notes>
+</file>
+
+<file path=ppt/notesSlides/notesSlide9.xml><?xml version="1.0" encoding="utf-8"?>
+<p:notes xmlns:a="http://schemas.openxmlformats.org/drawingml/2006/main" xmlns:r="http://schemas.openxmlformats.org/officeDocument/2006/relationships" xmlns:p="http://schemas.openxmlformats.org/presentationml/2006/main">
+  <p:cSld>
+    <p:spTree>
+      <p:nvGrpSpPr>
+        <p:cNvPr id="1" name=""/>
+        <p:cNvGrpSpPr/>
+        <p:nvPr/>
+      </p:nvGrpSpPr>
+      <p:grpSpPr>
+        <a:xfrm>
+          <a:off x="0" y="0"/>
+          <a:ext cx="0" cy="0"/>
+          <a:chOff x="0" y="0"/>
+          <a:chExt cx="0" cy="0"/>
+        </a:xfrm>
+      </p:grpSpPr>
+      <p:sp>
+        <p:nvSpPr>
+          <p:cNvPr id="2" name="Slide Image Placeholder 1"/>
+          <p:cNvSpPr>
+            <a:spLocks noGrp="1" noRot="1" noChangeAspect="1"/>
+          </p:cNvSpPr>
+          <p:nvPr>
+            <p:ph type="sldImg"/>
+          </p:nvPr>
+        </p:nvSpPr>
+        <p:spPr/>
+      </p:sp>
+      <p:sp>
+        <p:nvSpPr>
+          <p:cNvPr id="3" name="Notes Placeholder 2"/>
+          <p:cNvSpPr>
+            <a:spLocks noGrp="1"/>
+          </p:cNvSpPr>
+          <p:nvPr>
+            <p:ph type="body" idx="1"/>
+          </p:nvPr>
+        </p:nvSpPr>
+        <p:spPr/>
+        <p:txBody>
+          <a:bodyPr/>
+          <a:lstStyle/>
+          <a:p>
+            <a:r>
+              <a:rPr lang="en-US" dirty="0"/>
+              <a:t/>
+            </a:r>
+            <a:endParaRPr lang="en-US" dirty="0"/>
+          </a:p>
+        </p:txBody>
+      </p:sp>
+      <p:sp>
+        <p:nvSpPr>
+          <p:cNvPr id="4" name="Slide Number Placeholder 3"/>
+          <p:cNvSpPr>
+            <a:spLocks noGrp="1"/>
+          </p:cNvSpPr>
+          <p:nvPr>
+            <p:ph type="sldNum" sz="quarter" idx="10"/>
+          </p:nvPr>
+        </p:nvSpPr>
+        <p:spPr/>
+        <p:txBody>
+          <a:bodyPr/>
+          <a:lstStyle/>
+          <a:p>
+            <a:fld id="{F7021451-1387-4CA6-816F-3879F97B5CBC}" type="slidenum">
+              <a:rPr lang="en-US"/>
+              <a:t>9</a:t>
             </a:fld>
             <a:endParaRPr lang="en-US"/>
           </a:p>
@@ -1388,6 +1655,13 @@
 <file path=ppt/slides/slide1.xml><?xml version="1.0" encoding="utf-8"?>
 <p:sld xmlns:a="http://schemas.openxmlformats.org/drawingml/2006/main" xmlns:r="http://schemas.openxmlformats.org/officeDocument/2006/relationships" xmlns:p="http://schemas.openxmlformats.org/presentationml/2006/main">
   <p:cSld name="Slide 1">
+    <p:bg>
+      <p:bgPr>
+        <a:solidFill>
+          <a:srgbClr val="2A9D8F"/>
+        </a:solidFill>
+      </p:bgPr>
+    </p:bg>
     <p:spTree>
       <p:nvGrpSpPr>
         <p:cNvPr id="1" name=""/>
@@ -1410,55 +1684,15 @@
         </p:nvSpPr>
         <p:spPr>
           <a:xfrm>
-            <a:off x="0" y="0"/>
-            <a:ext cx="9144000" cy="5143500"/>
-          </a:xfrm>
-          <a:prstGeom prst="rect">
+            <a:off x="7772400" y="-914400"/>
+            <a:ext cx="3657600" cy="3657600"/>
+          </a:xfrm>
+          <a:prstGeom prst="ellipse">
             <a:avLst/>
           </a:prstGeom>
           <a:solidFill>
-            <a:srgbClr val="1B2A4A"/>
-          </a:solidFill>
-          <a:ln/>
-        </p:spPr>
-      </p:sp>
-      <p:sp>
-        <p:nvSpPr>
-          <p:cNvPr id="3" name="Shape 1"/>
-          <p:cNvSpPr/>
-          <p:nvPr/>
-        </p:nvSpPr>
-        <p:spPr>
-          <a:xfrm>
-            <a:off x="0" y="4777740"/>
-            <a:ext cx="9144000" cy="365760"/>
-          </a:xfrm>
-          <a:prstGeom prst="rect">
-            <a:avLst/>
-          </a:prstGeom>
-          <a:solidFill>
-            <a:srgbClr val="2A9D8F"/>
-          </a:solidFill>
-          <a:ln/>
-        </p:spPr>
-      </p:sp>
-      <p:sp>
-        <p:nvSpPr>
-          <p:cNvPr id="4" name="Shape 2"/>
-          <p:cNvSpPr/>
-          <p:nvPr/>
-        </p:nvSpPr>
-        <p:spPr>
-          <a:xfrm>
-            <a:off x="6858000" y="-1371600"/>
-            <a:ext cx="4572000" cy="4572000"/>
-          </a:xfrm>
-          <a:prstGeom prst="ellipse">
-            <a:avLst/>
-          </a:prstGeom>
-          <a:solidFill>
-            <a:srgbClr val="2A9D8F">
-              <a:alpha val="12000"/>
+            <a:srgbClr val="FFFFFF">
+              <a:alpha val="8000"/>
             </a:srgbClr>
           </a:solidFill>
           <a:ln/>
@@ -1466,14 +1700,14 @@
       </p:sp>
       <p:sp>
         <p:nvSpPr>
-          <p:cNvPr id="5" name="Text 3"/>
+          <p:cNvPr id="3" name="Text 1"/>
           <p:cNvSpPr/>
           <p:nvPr/>
         </p:nvSpPr>
         <p:spPr>
           <a:xfrm>
-            <a:off x="731520" y="914400"/>
-            <a:ext cx="7680960" cy="457200"/>
+            <a:off x="731520" y="548640"/>
+            <a:ext cx="7315200" cy="365760"/>
           </a:xfrm>
           <a:prstGeom prst="rect">
             <a:avLst/>
@@ -1489,30 +1723,30 @@
               <a:buNone/>
             </a:pPr>
             <a:r>
-              <a:rPr lang="en-US" sz="1300" b="1" spc="500" kern="0" dirty="0">
+              <a:rPr lang="en-US" sz="1100" b="1" dirty="0">
                 <a:solidFill>
-                  <a:srgbClr val="2A9D8F"/>
+                  <a:srgbClr val="F2D68A"/>
                 </a:solidFill>
-                <a:latin typeface="Calibri" pitchFamily="34" charset="0"/>
-                <a:ea typeface="Calibri" pitchFamily="34" charset="-122"/>
-                <a:cs typeface="Calibri" pitchFamily="34" charset="-120"/>
+                <a:latin typeface="Arial" pitchFamily="34" charset="0"/>
+                <a:ea typeface="Arial" pitchFamily="34" charset="-122"/>
+                <a:cs typeface="Arial" pitchFamily="34" charset="-120"/>
               </a:rPr>
               <a:t>GRADE 6 MATHEMATICS</a:t>
             </a:r>
-            <a:endParaRPr lang="en-US" sz="1300" dirty="0"/>
-          </a:p>
-        </p:txBody>
-      </p:sp>
-      <p:sp>
-        <p:nvSpPr>
-          <p:cNvPr id="6" name="Text 4"/>
+            <a:endParaRPr lang="en-US" sz="1100" dirty="0"/>
+          </a:p>
+        </p:txBody>
+      </p:sp>
+      <p:sp>
+        <p:nvSpPr>
+          <p:cNvPr id="4" name="Text 2"/>
           <p:cNvSpPr/>
           <p:nvPr/>
         </p:nvSpPr>
         <p:spPr>
           <a:xfrm>
-            <a:off x="731520" y="1463040"/>
-            <a:ext cx="6858000" cy="1645920"/>
+            <a:off x="731520" y="1371600"/>
+            <a:ext cx="9144000" cy="1645920"/>
           </a:xfrm>
           <a:prstGeom prst="rect">
             <a:avLst/>
@@ -1521,14 +1755,17 @@
           <a:ln/>
         </p:spPr>
         <p:txBody>
-          <a:bodyPr wrap="square" rtlCol="0" anchor="t"/>
+          <a:bodyPr wrap="square" rtlCol="0" anchor="ctr"/>
           <a:lstStyle/>
           <a:p>
             <a:pPr indent="0" marL="0">
+              <a:lnSpc>
+                <a:spcPct val="110000"/>
+              </a:lnSpc>
               <a:buNone/>
             </a:pPr>
             <a:r>
-              <a:rPr lang="en-US" sz="3800" b="1" dirty="0">
+              <a:rPr lang="en-US" sz="3600" b="1" dirty="0">
                 <a:solidFill>
                   <a:srgbClr val="FFFFFF"/>
                 </a:solidFill>
@@ -1536,39 +1773,63 @@
                 <a:ea typeface="Georgia" pitchFamily="34" charset="-122"/>
                 <a:cs typeface="Georgia" pitchFamily="34" charset="-120"/>
               </a:rPr>
-              <a:t>Number Sense</a:t>
-            </a:r>
-            <a:endParaRPr lang="en-US" sz="3800" dirty="0"/>
-          </a:p>
+              <a:t>Full Revision — Number Sense</a:t>
+            </a:r>
+            <a:endParaRPr lang="en-US" sz="3600" dirty="0"/>
+          </a:p>
+        </p:txBody>
+      </p:sp>
+      <p:sp>
+        <p:nvSpPr>
+          <p:cNvPr id="5" name="Text 3"/>
+          <p:cNvSpPr/>
+          <p:nvPr/>
+        </p:nvSpPr>
+        <p:spPr>
+          <a:xfrm>
+            <a:off x="731520" y="3200400"/>
+            <a:ext cx="7315200" cy="548640"/>
+          </a:xfrm>
+          <a:prstGeom prst="rect">
+            <a:avLst/>
+          </a:prstGeom>
+          <a:noFill/>
+          <a:ln/>
+        </p:spPr>
+        <p:txBody>
+          <a:bodyPr wrap="square" rtlCol="0" anchor="ctr"/>
+          <a:lstStyle/>
           <a:p>
             <a:pPr indent="0" marL="0">
               <a:buNone/>
             </a:pPr>
             <a:r>
-              <a:rPr lang="en-US" sz="3800" b="1" dirty="0">
+              <a:rPr lang="en-US" sz="1600" dirty="0">
                 <a:solidFill>
-                  <a:srgbClr val="FFFFFF"/>
+                  <a:srgbClr val="FFFFFF">
+                    <a:alpha val="65000"/>
+                  </a:srgbClr>
                 </a:solidFill>
-                <a:latin typeface="Georgia" pitchFamily="34" charset="0"/>
-                <a:ea typeface="Georgia" pitchFamily="34" charset="-122"/>
-                <a:cs typeface="Georgia" pitchFamily="34" charset="-120"/>
+                <a:latin typeface="Arial" pitchFamily="34" charset="0"/>
+                <a:ea typeface="Arial" pitchFamily="34" charset="-122"/>
+                <a:cs typeface="Arial" pitchFamily="34" charset="-120"/>
               </a:rPr>
-              <a:t>Full Revision</a:t>
-            </a:r>
-            <a:endParaRPr lang="en-US" sz="3800" dirty="0"/>
-          </a:p>
-        </p:txBody>
-      </p:sp>
-      <p:sp>
-        <p:nvSpPr>
-          <p:cNvPr id="7" name="Text 5"/>
+              <a:t>Review all topics from Term 1</a:t>
+            </a:r>
+            <a:endParaRPr lang="en-US" sz="1600" dirty="0"/>
+          </a:p>
+        </p:txBody>
+      </p:sp>
+      <p:sp>
+        <p:nvSpPr>
+          <p:cNvPr id="6" name="Text 4"/>
           <p:cNvSpPr/>
           <p:nvPr/>
         </p:nvSpPr>
         <p:spPr>
           <a:xfrm>
-            <a:off x="731520" y="3200400"/>
-            <a:ext cx="6400800" cy="548640"/>
+            <a:off x="731520" y="4389120"/>
+            <a:ext cx="2743200" cy="320040"/>
           </a:xfrm>
           <a:prstGeom prst="rect">
             <a:avLst/>
@@ -1584,56 +1845,19 @@
               <a:buNone/>
             </a:pPr>
             <a:r>
-              <a:rPr lang="en-US" sz="1600" i="1" dirty="0">
+              <a:rPr lang="en-US" sz="1000" dirty="0">
                 <a:solidFill>
-                  <a:srgbClr val="9B9690"/>
+                  <a:srgbClr val="FFFFFF">
+                    <a:alpha val="40000"/>
+                  </a:srgbClr>
                 </a:solidFill>
-                <a:latin typeface="Calibri" pitchFamily="34" charset="0"/>
-                <a:ea typeface="Calibri" pitchFamily="34" charset="-122"/>
-                <a:cs typeface="Calibri" pitchFamily="34" charset="-120"/>
-              </a:rPr>
-              <a:t>Place value, operations, and number properties</a:t>
-            </a:r>
-            <a:endParaRPr lang="en-US" sz="1600" dirty="0"/>
-          </a:p>
-        </p:txBody>
-      </p:sp>
-      <p:sp>
-        <p:nvSpPr>
-          <p:cNvPr id="8" name="Text 6"/>
-          <p:cNvSpPr/>
-          <p:nvPr/>
-        </p:nvSpPr>
-        <p:spPr>
-          <a:xfrm>
-            <a:off x="731520" y="4297680"/>
-            <a:ext cx="2743200" cy="365760"/>
-          </a:xfrm>
-          <a:prstGeom prst="rect">
-            <a:avLst/>
-          </a:prstGeom>
-          <a:noFill/>
-          <a:ln/>
-        </p:spPr>
-        <p:txBody>
-          <a:bodyPr wrap="square" rtlCol="0" anchor="ctr"/>
-          <a:lstStyle/>
-          <a:p>
-            <a:pPr indent="0" marL="0">
-              <a:buNone/>
-            </a:pPr>
-            <a:r>
-              <a:rPr lang="en-US" sz="1100" dirty="0">
-                <a:solidFill>
-                  <a:srgbClr val="9B9690"/>
-                </a:solidFill>
-                <a:latin typeface="Calibri" pitchFamily="34" charset="0"/>
-                <a:ea typeface="Calibri" pitchFamily="34" charset="-122"/>
-                <a:cs typeface="Calibri" pitchFamily="34" charset="-120"/>
+                <a:latin typeface="Arial" pitchFamily="34" charset="0"/>
+                <a:ea typeface="Arial" pitchFamily="34" charset="-122"/>
+                <a:cs typeface="Arial" pitchFamily="34" charset="-120"/>
               </a:rPr>
               <a:t>mrzocchi.com</a:t>
             </a:r>
-            <a:endParaRPr lang="en-US" sz="1100" dirty="0"/>
+            <a:endParaRPr lang="en-US" sz="1000" dirty="0"/>
           </a:p>
         </p:txBody>
       </p:sp>
@@ -1645,9 +1869,16 @@
 </p:sld>
 </file>
 
-<file path=ppt/slides/slide2.xml><?xml version="1.0" encoding="utf-8"?>
+<file path=ppt/slides/slide10.xml><?xml version="1.0" encoding="utf-8"?>
 <p:sld xmlns:a="http://schemas.openxmlformats.org/drawingml/2006/main" xmlns:r="http://schemas.openxmlformats.org/officeDocument/2006/relationships" xmlns:p="http://schemas.openxmlformats.org/presentationml/2006/main">
-  <p:cSld name="Slide 2">
+  <p:cSld name="Slide 10">
+    <p:bg>
+      <p:bgPr>
+        <a:solidFill>
+          <a:srgbClr val="111D35"/>
+        </a:solidFill>
+      </p:bgPr>
+    </p:bg>
     <p:spTree>
       <p:nvGrpSpPr>
         <p:cNvPr id="1" name=""/>
@@ -1664,93 +1895,14 @@
       </p:grpSpPr>
       <p:sp>
         <p:nvSpPr>
-          <p:cNvPr id="2" name="Shape 0"/>
+          <p:cNvPr id="2" name="Text 0"/>
           <p:cNvSpPr/>
           <p:nvPr/>
         </p:nvSpPr>
         <p:spPr>
           <a:xfrm>
-            <a:off x="0" y="0"/>
-            <a:ext cx="9144000" cy="5143500"/>
-          </a:xfrm>
-          <a:prstGeom prst="rect">
-            <a:avLst/>
-          </a:prstGeom>
-          <a:solidFill>
-            <a:srgbClr val="1B2A4A"/>
-          </a:solidFill>
-          <a:ln/>
-        </p:spPr>
-      </p:sp>
-      <p:sp>
-        <p:nvSpPr>
-          <p:cNvPr id="3" name="Shape 1"/>
-          <p:cNvSpPr/>
-          <p:nvPr/>
-        </p:nvSpPr>
-        <p:spPr>
-          <a:xfrm>
-            <a:off x="731520" y="1828800"/>
-            <a:ext cx="73152" cy="1463040"/>
-          </a:xfrm>
-          <a:prstGeom prst="rect">
-            <a:avLst/>
-          </a:prstGeom>
-          <a:solidFill>
-            <a:srgbClr val="2A9D8F"/>
-          </a:solidFill>
-          <a:ln/>
-        </p:spPr>
-      </p:sp>
-      <p:sp>
-        <p:nvSpPr>
-          <p:cNvPr id="4" name="Text 2"/>
-          <p:cNvSpPr/>
-          <p:nvPr/>
-        </p:nvSpPr>
-        <p:spPr>
-          <a:xfrm>
-            <a:off x="1097280" y="1463040"/>
-            <a:ext cx="1097280" cy="1097280"/>
-          </a:xfrm>
-          <a:prstGeom prst="rect">
-            <a:avLst/>
-          </a:prstGeom>
-          <a:noFill/>
-          <a:ln/>
-        </p:spPr>
-        <p:txBody>
-          <a:bodyPr wrap="square" rtlCol="0" anchor="ctr"/>
-          <a:lstStyle/>
-          <a:p>
-            <a:pPr algn="l" indent="0" marL="0">
-              <a:buNone/>
-            </a:pPr>
-            <a:r>
-              <a:rPr lang="en-US" sz="4800" b="1" dirty="0">
-                <a:solidFill>
-                  <a:srgbClr val="2A9D8F"/>
-                </a:solidFill>
-                <a:latin typeface="Georgia" pitchFamily="34" charset="0"/>
-                <a:ea typeface="Georgia" pitchFamily="34" charset="-122"/>
-                <a:cs typeface="Georgia" pitchFamily="34" charset="-120"/>
-              </a:rPr>
-              <a:t>1</a:t>
-            </a:r>
-            <a:endParaRPr lang="en-US" sz="4800" dirty="0"/>
-          </a:p>
-        </p:txBody>
-      </p:sp>
-      <p:sp>
-        <p:nvSpPr>
-          <p:cNvPr id="5" name="Text 3"/>
-          <p:cNvSpPr/>
-          <p:nvPr/>
-        </p:nvSpPr>
-        <p:spPr>
-          <a:xfrm>
-            <a:off x="2194560" y="1920240"/>
-            <a:ext cx="5943600" cy="1097280"/>
+            <a:off x="731520" y="1371600"/>
+            <a:ext cx="9144000" cy="914400"/>
           </a:xfrm>
           <a:prstGeom prst="rect">
             <a:avLst/>
@@ -1774,7 +1926,199 @@
                 <a:ea typeface="Georgia" pitchFamily="34" charset="-122"/>
                 <a:cs typeface="Georgia" pitchFamily="34" charset="-120"/>
               </a:rPr>
-              <a:t>Place Value &amp; Rounding</a:t>
+              <a:t>Review &amp; Practise</a:t>
+            </a:r>
+            <a:endParaRPr lang="en-US" sz="3200" dirty="0"/>
+          </a:p>
+        </p:txBody>
+      </p:sp>
+      <p:sp>
+        <p:nvSpPr>
+          <p:cNvPr id="3" name="Text 1"/>
+          <p:cNvSpPr/>
+          <p:nvPr/>
+        </p:nvSpPr>
+        <p:spPr>
+          <a:xfrm>
+            <a:off x="731520" y="2377440"/>
+            <a:ext cx="7315200" cy="548640"/>
+          </a:xfrm>
+          <a:prstGeom prst="rect">
+            <a:avLst/>
+          </a:prstGeom>
+          <a:noFill/>
+          <a:ln/>
+        </p:spPr>
+        <p:txBody>
+          <a:bodyPr wrap="square" rtlCol="0" anchor="ctr"/>
+          <a:lstStyle/>
+          <a:p>
+            <a:pPr indent="0" marL="0">
+              <a:buNone/>
+            </a:pPr>
+            <a:r>
+              <a:rPr lang="en-US" sz="1500" dirty="0">
+                <a:solidFill>
+                  <a:srgbClr val="FFFFFF">
+                    <a:alpha val="60000"/>
+                  </a:srgbClr>
+                </a:solidFill>
+                <a:latin typeface="Arial" pitchFamily="34" charset="0"/>
+                <a:ea typeface="Arial" pitchFamily="34" charset="-122"/>
+                <a:cs typeface="Arial" pitchFamily="34" charset="-120"/>
+              </a:rPr>
+              <a:t>Use the Self-Quiz, Review Games, and Practice Builder to test yourself.</a:t>
+            </a:r>
+            <a:endParaRPr lang="en-US" sz="1500" dirty="0"/>
+          </a:p>
+        </p:txBody>
+      </p:sp>
+      <p:sp>
+        <p:nvSpPr>
+          <p:cNvPr id="4" name="Text 2"/>
+          <p:cNvSpPr/>
+          <p:nvPr/>
+        </p:nvSpPr>
+        <p:spPr>
+          <a:xfrm>
+            <a:off x="731520" y="3291840"/>
+            <a:ext cx="3657600" cy="457200"/>
+          </a:xfrm>
+          <a:prstGeom prst="rect">
+            <a:avLst/>
+          </a:prstGeom>
+          <a:noFill/>
+          <a:ln/>
+        </p:spPr>
+        <p:txBody>
+          <a:bodyPr wrap="square" rtlCol="0" anchor="ctr"/>
+          <a:lstStyle/>
+          <a:p>
+            <a:pPr indent="0" marL="0">
+              <a:buNone/>
+            </a:pPr>
+            <a:r>
+              <a:rPr lang="en-US" sz="1800" b="1" dirty="0">
+                <a:solidFill>
+                  <a:srgbClr val="E9C46A"/>
+                </a:solidFill>
+                <a:latin typeface="Georgia" pitchFamily="34" charset="0"/>
+                <a:ea typeface="Georgia" pitchFamily="34" charset="-122"/>
+                <a:cs typeface="Georgia" pitchFamily="34" charset="-120"/>
+              </a:rPr>
+              <a:t>mrzocchi.com</a:t>
+            </a:r>
+            <a:endParaRPr lang="en-US" sz="1800" dirty="0"/>
+          </a:p>
+        </p:txBody>
+      </p:sp>
+    </p:spTree>
+  </p:cSld>
+  <p:clrMapOvr>
+    <a:masterClrMapping/>
+  </p:clrMapOvr>
+</p:sld>
+</file>
+
+<file path=ppt/slides/slide2.xml><?xml version="1.0" encoding="utf-8"?>
+<p:sld xmlns:a="http://schemas.openxmlformats.org/drawingml/2006/main" xmlns:r="http://schemas.openxmlformats.org/officeDocument/2006/relationships" xmlns:p="http://schemas.openxmlformats.org/presentationml/2006/main">
+  <p:cSld name="Slide 2">
+    <p:bg>
+      <p:bgPr>
+        <a:solidFill>
+          <a:srgbClr val="111D35"/>
+        </a:solidFill>
+      </p:bgPr>
+    </p:bg>
+    <p:spTree>
+      <p:nvGrpSpPr>
+        <p:cNvPr id="1" name=""/>
+        <p:cNvGrpSpPr/>
+        <p:nvPr/>
+      </p:nvGrpSpPr>
+      <p:grpSpPr>
+        <a:xfrm>
+          <a:off x="0" y="0"/>
+          <a:ext cx="0" cy="0"/>
+          <a:chOff x="0" y="0"/>
+          <a:chExt cx="0" cy="0"/>
+        </a:xfrm>
+      </p:grpSpPr>
+      <p:sp>
+        <p:nvSpPr>
+          <p:cNvPr id="2" name="Text 0"/>
+          <p:cNvSpPr/>
+          <p:nvPr/>
+        </p:nvSpPr>
+        <p:spPr>
+          <a:xfrm>
+            <a:off x="731520" y="731520"/>
+            <a:ext cx="2286000" cy="1828800"/>
+          </a:xfrm>
+          <a:prstGeom prst="rect">
+            <a:avLst/>
+          </a:prstGeom>
+          <a:noFill/>
+          <a:ln/>
+        </p:spPr>
+        <p:txBody>
+          <a:bodyPr wrap="square" rtlCol="0" anchor="ctr"/>
+          <a:lstStyle/>
+          <a:p>
+            <a:pPr indent="0" marL="0">
+              <a:buNone/>
+            </a:pPr>
+            <a:r>
+              <a:rPr lang="en-US" sz="7200" b="1" dirty="0">
+                <a:solidFill>
+                  <a:srgbClr val="2A9D8F">
+                    <a:alpha val="80000"/>
+                  </a:srgbClr>
+                </a:solidFill>
+                <a:latin typeface="Georgia" pitchFamily="34" charset="0"/>
+                <a:ea typeface="Georgia" pitchFamily="34" charset="-122"/>
+                <a:cs typeface="Georgia" pitchFamily="34" charset="-120"/>
+              </a:rPr>
+              <a:t>01</a:t>
+            </a:r>
+            <a:endParaRPr lang="en-US" sz="7200" dirty="0"/>
+          </a:p>
+        </p:txBody>
+      </p:sp>
+      <p:sp>
+        <p:nvSpPr>
+          <p:cNvPr id="3" name="Text 1"/>
+          <p:cNvSpPr/>
+          <p:nvPr/>
+        </p:nvSpPr>
+        <p:spPr>
+          <a:xfrm>
+            <a:off x="731520" y="1828800"/>
+            <a:ext cx="9144000" cy="1097280"/>
+          </a:xfrm>
+          <a:prstGeom prst="rect">
+            <a:avLst/>
+          </a:prstGeom>
+          <a:noFill/>
+          <a:ln/>
+        </p:spPr>
+        <p:txBody>
+          <a:bodyPr wrap="square" rtlCol="0" anchor="ctr"/>
+          <a:lstStyle/>
+          <a:p>
+            <a:pPr indent="0" marL="0">
+              <a:buNone/>
+            </a:pPr>
+            <a:r>
+              <a:rPr lang="en-US" sz="3200" b="1" dirty="0">
+                <a:solidFill>
+                  <a:srgbClr val="FFFFFF"/>
+                </a:solidFill>
+                <a:latin typeface="Georgia" pitchFamily="34" charset="0"/>
+                <a:ea typeface="Georgia" pitchFamily="34" charset="-122"/>
+                <a:cs typeface="Georgia" pitchFamily="34" charset="-120"/>
+              </a:rPr>
+              <a:t>Place Value</a:t>
             </a:r>
             <a:endParaRPr lang="en-US" sz="3200" dirty="0"/>
           </a:p>
@@ -1821,47 +2165,7 @@
         <p:spPr>
           <a:xfrm>
             <a:off x="0" y="0"/>
-            <a:ext cx="9144000" cy="822960"/>
-          </a:xfrm>
-          <a:prstGeom prst="rect">
-            <a:avLst/>
-          </a:prstGeom>
-          <a:solidFill>
-            <a:srgbClr val="FFFFFF"/>
-          </a:solidFill>
-          <a:ln/>
-        </p:spPr>
-      </p:sp>
-      <p:sp>
-        <p:nvSpPr>
-          <p:cNvPr id="3" name="Shape 1"/>
-          <p:cNvSpPr/>
-          <p:nvPr/>
-        </p:nvSpPr>
-        <p:spPr>
-          <a:xfrm>
-            <a:off x="0" y="804672"/>
-            <a:ext cx="9144000" cy="27432"/>
-          </a:xfrm>
-          <a:prstGeom prst="rect">
-            <a:avLst/>
-          </a:prstGeom>
-          <a:solidFill>
-            <a:srgbClr val="E5E2DC"/>
-          </a:solidFill>
-          <a:ln/>
-        </p:spPr>
-      </p:sp>
-      <p:sp>
-        <p:nvSpPr>
-          <p:cNvPr id="4" name="Shape 2"/>
-          <p:cNvSpPr/>
-          <p:nvPr/>
-        </p:nvSpPr>
-        <p:spPr>
-          <a:xfrm>
-            <a:off x="548640" y="201168"/>
-            <a:ext cx="54864" cy="420624"/>
+            <a:ext cx="73152" cy="5148072"/>
           </a:xfrm>
           <a:prstGeom prst="rect">
             <a:avLst/>
@@ -1874,14 +2178,14 @@
       </p:sp>
       <p:sp>
         <p:nvSpPr>
-          <p:cNvPr id="5" name="Text 3"/>
+          <p:cNvPr id="3" name="Text 1"/>
           <p:cNvSpPr/>
           <p:nvPr/>
         </p:nvSpPr>
         <p:spPr>
           <a:xfrm>
-            <a:off x="777240" y="137160"/>
-            <a:ext cx="7772400" cy="548640"/>
+            <a:off x="548640" y="274320"/>
+            <a:ext cx="9144000" cy="640080"/>
           </a:xfrm>
           <a:prstGeom prst="rect">
             <a:avLst/>
@@ -1890,14 +2194,14 @@
           <a:ln/>
         </p:spPr>
         <p:txBody>
-          <a:bodyPr wrap="square" lIns="0" tIns="0" rIns="0" bIns="0" rtlCol="0" anchor="ctr"/>
+          <a:bodyPr wrap="square" rtlCol="0" anchor="ctr"/>
           <a:lstStyle/>
           <a:p>
             <a:pPr indent="0" marL="0">
               <a:buNone/>
             </a:pPr>
             <a:r>
-              <a:rPr lang="en-US" sz="2000" b="1" dirty="0">
+              <a:rPr lang="en-US" sz="2400" b="1" dirty="0">
                 <a:solidFill>
                   <a:srgbClr val="1B2A4A"/>
                 </a:solidFill>
@@ -1905,22 +2209,42 @@
                 <a:ea typeface="Georgia" pitchFamily="34" charset="-122"/>
                 <a:cs typeface="Georgia" pitchFamily="34" charset="-120"/>
               </a:rPr>
-              <a:t>Numbers Review</a:t>
-            </a:r>
-            <a:endParaRPr lang="en-US" sz="2000" dirty="0"/>
-          </a:p>
-        </p:txBody>
-      </p:sp>
-      <p:sp>
-        <p:nvSpPr>
-          <p:cNvPr id="6" name="Text 4"/>
+              <a:t>Place Value Recap</a:t>
+            </a:r>
+            <a:endParaRPr lang="en-US" sz="2400" dirty="0"/>
+          </a:p>
+        </p:txBody>
+      </p:sp>
+      <p:sp>
+        <p:nvSpPr>
+          <p:cNvPr id="4" name="Shape 2"/>
           <p:cNvSpPr/>
           <p:nvPr/>
         </p:nvSpPr>
         <p:spPr>
           <a:xfrm>
-            <a:off x="731520" y="1051560"/>
-            <a:ext cx="7680960" cy="3108960"/>
+            <a:off x="548640" y="960120"/>
+            <a:ext cx="2286000" cy="36576"/>
+          </a:xfrm>
+          <a:prstGeom prst="rect">
+            <a:avLst/>
+          </a:prstGeom>
+          <a:solidFill>
+            <a:srgbClr val="2A9D8F"/>
+          </a:solidFill>
+          <a:ln/>
+        </p:spPr>
+      </p:sp>
+      <p:sp>
+        <p:nvSpPr>
+          <p:cNvPr id="5" name="Text 3"/>
+          <p:cNvSpPr/>
+          <p:nvPr/>
+        </p:nvSpPr>
+        <p:spPr>
+          <a:xfrm>
+            <a:off x="548640" y="1188720"/>
+            <a:ext cx="10058400" cy="3474720"/>
           </a:xfrm>
           <a:prstGeom prst="rect">
             <a:avLst/>
@@ -1932,107 +2256,68 @@
           <a:bodyPr wrap="square" rtlCol="0" anchor="t"/>
           <a:lstStyle/>
           <a:p>
-            <a:pPr marL="342900" indent="-342900">
+            <a:pPr>
+              <a:lnSpc>
+                <a:spcPct val="150000"/>
+              </a:lnSpc>
               <a:spcAft>
-                <a:spcPts val="800"/>
+                <a:spcPts val="600"/>
               </a:spcAft>
-              <a:buSzPct val="100000"/>
-              <a:buChar char="•"/>
             </a:pPr>
             <a:r>
               <a:rPr lang="en-US" sz="1500" dirty="0">
                 <a:solidFill>
                   <a:srgbClr val="3D3A36"/>
                 </a:solidFill>
-                <a:latin typeface="Calibri" pitchFamily="34" charset="0"/>
-                <a:ea typeface="Calibri" pitchFamily="34" charset="-122"/>
-                <a:cs typeface="Calibri" pitchFamily="34" charset="-120"/>
+                <a:latin typeface="Arial" pitchFamily="34" charset="0"/>
+                <a:ea typeface="Arial" pitchFamily="34" charset="-122"/>
+                <a:cs typeface="Arial" pitchFamily="34" charset="-120"/>
               </a:rPr>
-              <a:t>Place value: each position is 10× bigger than the one to its right.</a:t>
+              <a:t>Each digit has a value based on its position.</a:t>
             </a:r>
             <a:endParaRPr lang="en-US" sz="1500" dirty="0"/>
           </a:p>
           <a:p>
-            <a:pPr marL="342900" indent="-342900">
+            <a:pPr>
+              <a:lnSpc>
+                <a:spcPct val="150000"/>
+              </a:lnSpc>
               <a:spcAft>
-                <a:spcPts val="800"/>
+                <a:spcPts val="600"/>
               </a:spcAft>
-              <a:buSzPct val="100000"/>
-              <a:buChar char="•"/>
             </a:pPr>
             <a:r>
               <a:rPr lang="en-US" sz="1500" dirty="0">
                 <a:solidFill>
                   <a:srgbClr val="3D3A36"/>
                 </a:solidFill>
-                <a:latin typeface="Calibri" pitchFamily="34" charset="0"/>
-                <a:ea typeface="Calibri" pitchFamily="34" charset="-122"/>
-                <a:cs typeface="Calibri" pitchFamily="34" charset="-120"/>
+                <a:latin typeface="Arial" pitchFamily="34" charset="0"/>
+                <a:ea typeface="Arial" pitchFamily="34" charset="-122"/>
+                <a:cs typeface="Arial" pitchFamily="34" charset="-120"/>
               </a:rPr>
-              <a:t>Rounding: look at the digit to the RIGHT of your target. 5+ = round up, 0–4 = round down.</a:t>
+              <a:t>× 10 moves digits left, ÷ 10 moves digits right.</a:t>
             </a:r>
             <a:endParaRPr lang="en-US" sz="1500" dirty="0"/>
           </a:p>
           <a:p>
-            <a:pPr marL="342900" indent="-342900">
+            <a:pPr>
+              <a:lnSpc>
+                <a:spcPct val="150000"/>
+              </a:lnSpc>
               <a:spcAft>
-                <a:spcPts val="800"/>
+                <a:spcPts val="600"/>
               </a:spcAft>
-              <a:buSzPct val="100000"/>
-              <a:buChar char="•"/>
             </a:pPr>
             <a:r>
               <a:rPr lang="en-US" sz="1500" dirty="0">
                 <a:solidFill>
                   <a:srgbClr val="3D3A36"/>
                 </a:solidFill>
-                <a:latin typeface="Calibri" pitchFamily="34" charset="0"/>
-                <a:ea typeface="Calibri" pitchFamily="34" charset="-122"/>
-                <a:cs typeface="Calibri" pitchFamily="34" charset="-120"/>
+                <a:latin typeface="Arial" pitchFamily="34" charset="0"/>
+                <a:ea typeface="Arial" pitchFamily="34" charset="-122"/>
+                <a:cs typeface="Arial" pitchFamily="34" charset="-120"/>
               </a:rPr>
-              <a:t>BIDMAS: Brackets → Indices → Division/Multiplication → Addition/Subtraction.</a:t>
-            </a:r>
-            <a:endParaRPr lang="en-US" sz="1500" dirty="0"/>
-          </a:p>
-          <a:p>
-            <a:pPr marL="342900" indent="-342900">
-              <a:spcAft>
-                <a:spcPts val="800"/>
-              </a:spcAft>
-              <a:buSzPct val="100000"/>
-              <a:buChar char="•"/>
-            </a:pPr>
-            <a:r>
-              <a:rPr lang="en-US" sz="1500" dirty="0">
-                <a:solidFill>
-                  <a:srgbClr val="3D3A36"/>
-                </a:solidFill>
-                <a:latin typeface="Calibri" pitchFamily="34" charset="0"/>
-                <a:ea typeface="Calibri" pitchFamily="34" charset="-122"/>
-                <a:cs typeface="Calibri" pitchFamily="34" charset="-120"/>
-              </a:rPr>
-              <a:t>Negative numbers: same signs = positive result, different signs = negative.</a:t>
-            </a:r>
-            <a:endParaRPr lang="en-US" sz="1500" dirty="0"/>
-          </a:p>
-          <a:p>
-            <a:pPr marL="342900" indent="-342900">
-              <a:spcAft>
-                <a:spcPts val="800"/>
-              </a:spcAft>
-              <a:buSzPct val="100000"/>
-              <a:buChar char="•"/>
-            </a:pPr>
-            <a:r>
-              <a:rPr lang="en-US" sz="1500" dirty="0">
-                <a:solidFill>
-                  <a:srgbClr val="3D3A36"/>
-                </a:solidFill>
-                <a:latin typeface="Calibri" pitchFamily="34" charset="0"/>
-                <a:ea typeface="Calibri" pitchFamily="34" charset="-122"/>
-                <a:cs typeface="Calibri" pitchFamily="34" charset="-120"/>
-              </a:rPr>
-              <a:t>Factors divide IN, multiples multiply OUT, primes have exactly 2 factors.</a:t>
+              <a:t>Compare from left to right. Use &lt; &gt; = correctly.</a:t>
             </a:r>
             <a:endParaRPr lang="en-US" sz="1500" dirty="0"/>
           </a:p>
@@ -2049,6 +2334,13 @@
 <file path=ppt/slides/slide4.xml><?xml version="1.0" encoding="utf-8"?>
 <p:sld xmlns:a="http://schemas.openxmlformats.org/drawingml/2006/main" xmlns:r="http://schemas.openxmlformats.org/officeDocument/2006/relationships" xmlns:p="http://schemas.openxmlformats.org/presentationml/2006/main">
   <p:cSld name="Slide 4">
+    <p:bg>
+      <p:bgPr>
+        <a:solidFill>
+          <a:srgbClr val="111D35"/>
+        </a:solidFill>
+      </p:bgPr>
+    </p:bg>
     <p:spTree>
       <p:nvGrpSpPr>
         <p:cNvPr id="1" name=""/>
@@ -2065,54 +2357,14 @@
       </p:grpSpPr>
       <p:sp>
         <p:nvSpPr>
-          <p:cNvPr id="2" name="Shape 0"/>
+          <p:cNvPr id="2" name="Text 0"/>
           <p:cNvSpPr/>
           <p:nvPr/>
         </p:nvSpPr>
         <p:spPr>
           <a:xfrm>
-            <a:off x="0" y="0"/>
-            <a:ext cx="9144000" cy="5143500"/>
-          </a:xfrm>
-          <a:prstGeom prst="rect">
-            <a:avLst/>
-          </a:prstGeom>
-          <a:solidFill>
-            <a:srgbClr val="1B2A4A"/>
-          </a:solidFill>
-          <a:ln/>
-        </p:spPr>
-      </p:sp>
-      <p:sp>
-        <p:nvSpPr>
-          <p:cNvPr id="3" name="Shape 1"/>
-          <p:cNvSpPr/>
-          <p:nvPr/>
-        </p:nvSpPr>
-        <p:spPr>
-          <a:xfrm>
-            <a:off x="731520" y="1828800"/>
-            <a:ext cx="73152" cy="1463040"/>
-          </a:xfrm>
-          <a:prstGeom prst="rect">
-            <a:avLst/>
-          </a:prstGeom>
-          <a:solidFill>
-            <a:srgbClr val="2A9D8F"/>
-          </a:solidFill>
-          <a:ln/>
-        </p:spPr>
-      </p:sp>
-      <p:sp>
-        <p:nvSpPr>
-          <p:cNvPr id="4" name="Text 2"/>
-          <p:cNvSpPr/>
-          <p:nvPr/>
-        </p:nvSpPr>
-        <p:spPr>
-          <a:xfrm>
-            <a:off x="1097280" y="1463040"/>
-            <a:ext cx="1097280" cy="1097280"/>
+            <a:off x="731520" y="731520"/>
+            <a:ext cx="2286000" cy="1828800"/>
           </a:xfrm>
           <a:prstGeom prst="rect">
             <a:avLst/>
@@ -2124,34 +2376,36 @@
           <a:bodyPr wrap="square" rtlCol="0" anchor="ctr"/>
           <a:lstStyle/>
           <a:p>
-            <a:pPr algn="l" indent="0" marL="0">
+            <a:pPr indent="0" marL="0">
               <a:buNone/>
             </a:pPr>
             <a:r>
-              <a:rPr lang="en-US" sz="4800" b="1" dirty="0">
+              <a:rPr lang="en-US" sz="7200" b="1" dirty="0">
                 <a:solidFill>
-                  <a:srgbClr val="2A9D8F"/>
+                  <a:srgbClr val="2A9D8F">
+                    <a:alpha val="80000"/>
+                  </a:srgbClr>
                 </a:solidFill>
                 <a:latin typeface="Georgia" pitchFamily="34" charset="0"/>
                 <a:ea typeface="Georgia" pitchFamily="34" charset="-122"/>
                 <a:cs typeface="Georgia" pitchFamily="34" charset="-120"/>
               </a:rPr>
-              <a:t>2</a:t>
-            </a:r>
-            <a:endParaRPr lang="en-US" sz="4800" dirty="0"/>
-          </a:p>
-        </p:txBody>
-      </p:sp>
-      <p:sp>
-        <p:nvSpPr>
-          <p:cNvPr id="5" name="Text 3"/>
+              <a:t>02</a:t>
+            </a:r>
+            <a:endParaRPr lang="en-US" sz="7200" dirty="0"/>
+          </a:p>
+        </p:txBody>
+      </p:sp>
+      <p:sp>
+        <p:nvSpPr>
+          <p:cNvPr id="3" name="Text 1"/>
           <p:cNvSpPr/>
           <p:nvPr/>
         </p:nvSpPr>
         <p:spPr>
           <a:xfrm>
-            <a:off x="2194560" y="1920240"/>
-            <a:ext cx="5943600" cy="1097280"/>
+            <a:off x="731520" y="1828800"/>
+            <a:ext cx="9144000" cy="1097280"/>
           </a:xfrm>
           <a:prstGeom prst="rect">
             <a:avLst/>
@@ -2175,7 +2429,7 @@
                 <a:ea typeface="Georgia" pitchFamily="34" charset="-122"/>
                 <a:cs typeface="Georgia" pitchFamily="34" charset="-120"/>
               </a:rPr>
-              <a:t>Key Skills</a:t>
+              <a:t>Rounding</a:t>
             </a:r>
             <a:endParaRPr lang="en-US" sz="3200" dirty="0"/>
           </a:p>
@@ -2222,47 +2476,7 @@
         <p:spPr>
           <a:xfrm>
             <a:off x="0" y="0"/>
-            <a:ext cx="9144000" cy="822960"/>
-          </a:xfrm>
-          <a:prstGeom prst="rect">
-            <a:avLst/>
-          </a:prstGeom>
-          <a:solidFill>
-            <a:srgbClr val="FFFFFF"/>
-          </a:solidFill>
-          <a:ln/>
-        </p:spPr>
-      </p:sp>
-      <p:sp>
-        <p:nvSpPr>
-          <p:cNvPr id="3" name="Shape 1"/>
-          <p:cNvSpPr/>
-          <p:nvPr/>
-        </p:nvSpPr>
-        <p:spPr>
-          <a:xfrm>
-            <a:off x="0" y="804672"/>
-            <a:ext cx="9144000" cy="27432"/>
-          </a:xfrm>
-          <a:prstGeom prst="rect">
-            <a:avLst/>
-          </a:prstGeom>
-          <a:solidFill>
-            <a:srgbClr val="E5E2DC"/>
-          </a:solidFill>
-          <a:ln/>
-        </p:spPr>
-      </p:sp>
-      <p:sp>
-        <p:nvSpPr>
-          <p:cNvPr id="4" name="Shape 2"/>
-          <p:cNvSpPr/>
-          <p:nvPr/>
-        </p:nvSpPr>
-        <p:spPr>
-          <a:xfrm>
-            <a:off x="548640" y="201168"/>
-            <a:ext cx="54864" cy="420624"/>
+            <a:ext cx="73152" cy="5148072"/>
           </a:xfrm>
           <a:prstGeom prst="rect">
             <a:avLst/>
@@ -2275,14 +2489,14 @@
       </p:sp>
       <p:sp>
         <p:nvSpPr>
-          <p:cNvPr id="5" name="Text 3"/>
+          <p:cNvPr id="3" name="Text 1"/>
           <p:cNvSpPr/>
           <p:nvPr/>
         </p:nvSpPr>
         <p:spPr>
           <a:xfrm>
-            <a:off x="777240" y="137160"/>
-            <a:ext cx="7772400" cy="548640"/>
+            <a:off x="548640" y="274320"/>
+            <a:ext cx="9144000" cy="640080"/>
           </a:xfrm>
           <a:prstGeom prst="rect">
             <a:avLst/>
@@ -2291,14 +2505,14 @@
           <a:ln/>
         </p:spPr>
         <p:txBody>
-          <a:bodyPr wrap="square" lIns="0" tIns="0" rIns="0" bIns="0" rtlCol="0" anchor="ctr"/>
+          <a:bodyPr wrap="square" rtlCol="0" anchor="ctr"/>
           <a:lstStyle/>
           <a:p>
             <a:pPr indent="0" marL="0">
               <a:buNone/>
             </a:pPr>
             <a:r>
-              <a:rPr lang="en-US" sz="2000" b="1" dirty="0">
+              <a:rPr lang="en-US" sz="2400" b="1" dirty="0">
                 <a:solidFill>
                   <a:srgbClr val="1B2A4A"/>
                 </a:solidFill>
@@ -2306,22 +2520,42 @@
                 <a:ea typeface="Georgia" pitchFamily="34" charset="-122"/>
                 <a:cs typeface="Georgia" pitchFamily="34" charset="-120"/>
               </a:rPr>
-              <a:t>Skills Review</a:t>
-            </a:r>
-            <a:endParaRPr lang="en-US" sz="2000" dirty="0"/>
-          </a:p>
-        </p:txBody>
-      </p:sp>
-      <p:sp>
-        <p:nvSpPr>
-          <p:cNvPr id="6" name="Text 4"/>
+              <a:t>Rounding Recap</a:t>
+            </a:r>
+            <a:endParaRPr lang="en-US" sz="2400" dirty="0"/>
+          </a:p>
+        </p:txBody>
+      </p:sp>
+      <p:sp>
+        <p:nvSpPr>
+          <p:cNvPr id="4" name="Shape 2"/>
           <p:cNvSpPr/>
           <p:nvPr/>
         </p:nvSpPr>
         <p:spPr>
           <a:xfrm>
-            <a:off x="731520" y="1051560"/>
-            <a:ext cx="7680960" cy="3108960"/>
+            <a:off x="548640" y="960120"/>
+            <a:ext cx="2286000" cy="36576"/>
+          </a:xfrm>
+          <a:prstGeom prst="rect">
+            <a:avLst/>
+          </a:prstGeom>
+          <a:solidFill>
+            <a:srgbClr val="2A9D8F"/>
+          </a:solidFill>
+          <a:ln/>
+        </p:spPr>
+      </p:sp>
+      <p:sp>
+        <p:nvSpPr>
+          <p:cNvPr id="5" name="Text 3"/>
+          <p:cNvSpPr/>
+          <p:nvPr/>
+        </p:nvSpPr>
+        <p:spPr>
+          <a:xfrm>
+            <a:off x="548640" y="1188720"/>
+            <a:ext cx="10058400" cy="3474720"/>
           </a:xfrm>
           <a:prstGeom prst="rect">
             <a:avLst/>
@@ -2333,107 +2567,46 @@
           <a:bodyPr wrap="square" rtlCol="0" anchor="t"/>
           <a:lstStyle/>
           <a:p>
-            <a:pPr marL="342900" indent="-342900">
+            <a:pPr>
+              <a:lnSpc>
+                <a:spcPct val="150000"/>
+              </a:lnSpc>
               <a:spcAft>
-                <a:spcPts val="800"/>
+                <a:spcPts val="600"/>
               </a:spcAft>
-              <a:buSzPct val="100000"/>
-              <a:buChar char="•"/>
             </a:pPr>
             <a:r>
               <a:rPr lang="en-US" sz="1500" dirty="0">
                 <a:solidFill>
                   <a:srgbClr val="3D3A36"/>
                 </a:solidFill>
-                <a:latin typeface="Calibri" pitchFamily="34" charset="0"/>
-                <a:ea typeface="Calibri" pitchFamily="34" charset="-122"/>
-                <a:cs typeface="Calibri" pitchFamily="34" charset="-120"/>
+                <a:latin typeface="Arial" pitchFamily="34" charset="0"/>
+                <a:ea typeface="Arial" pitchFamily="34" charset="-122"/>
+                <a:cs typeface="Arial" pitchFamily="34" charset="-120"/>
               </a:rPr>
-              <a:t>Compare numbers using place value columns (start from the left).</a:t>
+              <a:t>Look at the digit to the RIGHT. 5+ rounds up, &lt;5 rounds down.</a:t>
             </a:r>
             <a:endParaRPr lang="en-US" sz="1500" dirty="0"/>
           </a:p>
           <a:p>
-            <a:pPr marL="342900" indent="-342900">
+            <a:pPr>
+              <a:lnSpc>
+                <a:spcPct val="150000"/>
+              </a:lnSpc>
               <a:spcAft>
-                <a:spcPts val="800"/>
+                <a:spcPts val="600"/>
               </a:spcAft>
-              <a:buSzPct val="100000"/>
-              <a:buChar char="•"/>
             </a:pPr>
             <a:r>
               <a:rPr lang="en-US" sz="1500" dirty="0">
                 <a:solidFill>
                   <a:srgbClr val="3D3A36"/>
                 </a:solidFill>
-                <a:latin typeface="Calibri" pitchFamily="34" charset="0"/>
-                <a:ea typeface="Calibri" pitchFamily="34" charset="-122"/>
-                <a:cs typeface="Calibri" pitchFamily="34" charset="-120"/>
+                <a:latin typeface="Arial" pitchFamily="34" charset="0"/>
+                <a:ea typeface="Arial" pitchFamily="34" charset="-122"/>
+                <a:cs typeface="Arial" pitchFamily="34" charset="-120"/>
               </a:rPr>
-              <a:t>Use estimation to check your answers: round then calculate.</a:t>
-            </a:r>
-            <a:endParaRPr lang="en-US" sz="1500" dirty="0"/>
-          </a:p>
-          <a:p>
-            <a:pPr marL="342900" indent="-342900">
-              <a:spcAft>
-                <a:spcPts val="800"/>
-              </a:spcAft>
-              <a:buSzPct val="100000"/>
-              <a:buChar char="•"/>
-            </a:pPr>
-            <a:r>
-              <a:rPr lang="en-US" sz="1500" dirty="0">
-                <a:solidFill>
-                  <a:srgbClr val="3D3A36"/>
-                </a:solidFill>
-                <a:latin typeface="Calibri" pitchFamily="34" charset="0"/>
-                <a:ea typeface="Calibri" pitchFamily="34" charset="-122"/>
-                <a:cs typeface="Calibri" pitchFamily="34" charset="-120"/>
-              </a:rPr>
-              <a:t>Add/subtract negatives: use a number line. Two negatives = a positive (for multiplication).</a:t>
-            </a:r>
-            <a:endParaRPr lang="en-US" sz="1500" dirty="0"/>
-          </a:p>
-          <a:p>
-            <a:pPr marL="342900" indent="-342900">
-              <a:spcAft>
-                <a:spcPts val="800"/>
-              </a:spcAft>
-              <a:buSzPct val="100000"/>
-              <a:buChar char="•"/>
-            </a:pPr>
-            <a:r>
-              <a:rPr lang="en-US" sz="1500" dirty="0">
-                <a:solidFill>
-                  <a:srgbClr val="3D3A36"/>
-                </a:solidFill>
-                <a:latin typeface="Calibri" pitchFamily="34" charset="0"/>
-                <a:ea typeface="Calibri" pitchFamily="34" charset="-122"/>
-                <a:cs typeface="Calibri" pitchFamily="34" charset="-120"/>
-              </a:rPr>
-              <a:t>Find HCF by listing common factors. Find LCM by listing common multiples.</a:t>
-            </a:r>
-            <a:endParaRPr lang="en-US" sz="1500" dirty="0"/>
-          </a:p>
-          <a:p>
-            <a:pPr marL="342900" indent="-342900">
-              <a:spcAft>
-                <a:spcPts val="800"/>
-              </a:spcAft>
-              <a:buSzPct val="100000"/>
-              <a:buChar char="•"/>
-            </a:pPr>
-            <a:r>
-              <a:rPr lang="en-US" sz="1500" dirty="0">
-                <a:solidFill>
-                  <a:srgbClr val="3D3A36"/>
-                </a:solidFill>
-                <a:latin typeface="Calibri" pitchFamily="34" charset="0"/>
-                <a:ea typeface="Calibri" pitchFamily="34" charset="-122"/>
-                <a:cs typeface="Calibri" pitchFamily="34" charset="-120"/>
-              </a:rPr>
-              <a:t>All numbers &gt; 1 are either prime or composite.</a:t>
+              <a:t>Estimation: round, calculate, check if answer is reasonable.</a:t>
             </a:r>
             <a:endParaRPr lang="en-US" sz="1500" dirty="0"/>
           </a:p>
@@ -2450,6 +2623,118 @@
 <file path=ppt/slides/slide6.xml><?xml version="1.0" encoding="utf-8"?>
 <p:sld xmlns:a="http://schemas.openxmlformats.org/drawingml/2006/main" xmlns:r="http://schemas.openxmlformats.org/officeDocument/2006/relationships" xmlns:p="http://schemas.openxmlformats.org/presentationml/2006/main">
   <p:cSld name="Slide 6">
+    <p:bg>
+      <p:bgPr>
+        <a:solidFill>
+          <a:srgbClr val="111D35"/>
+        </a:solidFill>
+      </p:bgPr>
+    </p:bg>
+    <p:spTree>
+      <p:nvGrpSpPr>
+        <p:cNvPr id="1" name=""/>
+        <p:cNvGrpSpPr/>
+        <p:nvPr/>
+      </p:nvGrpSpPr>
+      <p:grpSpPr>
+        <a:xfrm>
+          <a:off x="0" y="0"/>
+          <a:ext cx="0" cy="0"/>
+          <a:chOff x="0" y="0"/>
+          <a:chExt cx="0" cy="0"/>
+        </a:xfrm>
+      </p:grpSpPr>
+      <p:sp>
+        <p:nvSpPr>
+          <p:cNvPr id="2" name="Text 0"/>
+          <p:cNvSpPr/>
+          <p:nvPr/>
+        </p:nvSpPr>
+        <p:spPr>
+          <a:xfrm>
+            <a:off x="731520" y="731520"/>
+            <a:ext cx="2286000" cy="1828800"/>
+          </a:xfrm>
+          <a:prstGeom prst="rect">
+            <a:avLst/>
+          </a:prstGeom>
+          <a:noFill/>
+          <a:ln/>
+        </p:spPr>
+        <p:txBody>
+          <a:bodyPr wrap="square" rtlCol="0" anchor="ctr"/>
+          <a:lstStyle/>
+          <a:p>
+            <a:pPr indent="0" marL="0">
+              <a:buNone/>
+            </a:pPr>
+            <a:r>
+              <a:rPr lang="en-US" sz="7200" b="1" dirty="0">
+                <a:solidFill>
+                  <a:srgbClr val="2A9D8F">
+                    <a:alpha val="80000"/>
+                  </a:srgbClr>
+                </a:solidFill>
+                <a:latin typeface="Georgia" pitchFamily="34" charset="0"/>
+                <a:ea typeface="Georgia" pitchFamily="34" charset="-122"/>
+                <a:cs typeface="Georgia" pitchFamily="34" charset="-120"/>
+              </a:rPr>
+              <a:t>03</a:t>
+            </a:r>
+            <a:endParaRPr lang="en-US" sz="7200" dirty="0"/>
+          </a:p>
+        </p:txBody>
+      </p:sp>
+      <p:sp>
+        <p:nvSpPr>
+          <p:cNvPr id="3" name="Text 1"/>
+          <p:cNvSpPr/>
+          <p:nvPr/>
+        </p:nvSpPr>
+        <p:spPr>
+          <a:xfrm>
+            <a:off x="731520" y="1828800"/>
+            <a:ext cx="9144000" cy="1097280"/>
+          </a:xfrm>
+          <a:prstGeom prst="rect">
+            <a:avLst/>
+          </a:prstGeom>
+          <a:noFill/>
+          <a:ln/>
+        </p:spPr>
+        <p:txBody>
+          <a:bodyPr wrap="square" rtlCol="0" anchor="ctr"/>
+          <a:lstStyle/>
+          <a:p>
+            <a:pPr indent="0" marL="0">
+              <a:buNone/>
+            </a:pPr>
+            <a:r>
+              <a:rPr lang="en-US" sz="3200" b="1" dirty="0">
+                <a:solidFill>
+                  <a:srgbClr val="FFFFFF"/>
+                </a:solidFill>
+                <a:latin typeface="Georgia" pitchFamily="34" charset="0"/>
+                <a:ea typeface="Georgia" pitchFamily="34" charset="-122"/>
+                <a:cs typeface="Georgia" pitchFamily="34" charset="-120"/>
+              </a:rPr>
+              <a:t>BIDMAS</a:t>
+            </a:r>
+            <a:endParaRPr lang="en-US" sz="3200" dirty="0"/>
+          </a:p>
+        </p:txBody>
+      </p:sp>
+    </p:spTree>
+  </p:cSld>
+  <p:clrMapOvr>
+    <a:masterClrMapping/>
+  </p:clrMapOvr>
+</p:sld>
+</file>
+
+<file path=ppt/slides/slide7.xml><?xml version="1.0" encoding="utf-8"?>
+<p:sld xmlns:a="http://schemas.openxmlformats.org/drawingml/2006/main" xmlns:r="http://schemas.openxmlformats.org/officeDocument/2006/relationships" xmlns:p="http://schemas.openxmlformats.org/presentationml/2006/main">
+  <p:cSld name="Slide 7">
     <p:bg>
       <p:bgPr>
         <a:solidFill>
@@ -2480,47 +2765,7 @@
         <p:spPr>
           <a:xfrm>
             <a:off x="0" y="0"/>
-            <a:ext cx="9144000" cy="822960"/>
-          </a:xfrm>
-          <a:prstGeom prst="rect">
-            <a:avLst/>
-          </a:prstGeom>
-          <a:solidFill>
-            <a:srgbClr val="FFFFFF"/>
-          </a:solidFill>
-          <a:ln/>
-        </p:spPr>
-      </p:sp>
-      <p:sp>
-        <p:nvSpPr>
-          <p:cNvPr id="3" name="Shape 1"/>
-          <p:cNvSpPr/>
-          <p:nvPr/>
-        </p:nvSpPr>
-        <p:spPr>
-          <a:xfrm>
-            <a:off x="0" y="804672"/>
-            <a:ext cx="9144000" cy="27432"/>
-          </a:xfrm>
-          <a:prstGeom prst="rect">
-            <a:avLst/>
-          </a:prstGeom>
-          <a:solidFill>
-            <a:srgbClr val="E5E2DC"/>
-          </a:solidFill>
-          <a:ln/>
-        </p:spPr>
-      </p:sp>
-      <p:sp>
-        <p:nvSpPr>
-          <p:cNvPr id="4" name="Shape 2"/>
-          <p:cNvSpPr/>
-          <p:nvPr/>
-        </p:nvSpPr>
-        <p:spPr>
-          <a:xfrm>
-            <a:off x="548640" y="201168"/>
-            <a:ext cx="54864" cy="420624"/>
+            <a:ext cx="73152" cy="5148072"/>
           </a:xfrm>
           <a:prstGeom prst="rect">
             <a:avLst/>
@@ -2533,14 +2778,14 @@
       </p:sp>
       <p:sp>
         <p:nvSpPr>
-          <p:cNvPr id="5" name="Text 3"/>
+          <p:cNvPr id="3" name="Text 1"/>
           <p:cNvSpPr/>
           <p:nvPr/>
         </p:nvSpPr>
         <p:spPr>
           <a:xfrm>
-            <a:off x="777240" y="137160"/>
-            <a:ext cx="7772400" cy="548640"/>
+            <a:off x="548640" y="274320"/>
+            <a:ext cx="9144000" cy="640080"/>
           </a:xfrm>
           <a:prstGeom prst="rect">
             <a:avLst/>
@@ -2549,14 +2794,14 @@
           <a:ln/>
         </p:spPr>
         <p:txBody>
-          <a:bodyPr wrap="square" lIns="0" tIns="0" rIns="0" bIns="0" rtlCol="0" anchor="ctr"/>
+          <a:bodyPr wrap="square" rtlCol="0" anchor="ctr"/>
           <a:lstStyle/>
           <a:p>
             <a:pPr indent="0" marL="0">
               <a:buNone/>
             </a:pPr>
             <a:r>
-              <a:rPr lang="en-US" sz="2000" b="1" dirty="0">
+              <a:rPr lang="en-US" sz="2400" b="1" dirty="0">
                 <a:solidFill>
                   <a:srgbClr val="1B2A4A"/>
                 </a:solidFill>
@@ -2564,42 +2809,42 @@
                 <a:ea typeface="Georgia" pitchFamily="34" charset="-122"/>
                 <a:cs typeface="Georgia" pitchFamily="34" charset="-120"/>
               </a:rPr>
-              <a:t>Final Revision Checklist</a:t>
-            </a:r>
-            <a:endParaRPr lang="en-US" sz="2000" dirty="0"/>
-          </a:p>
-        </p:txBody>
-      </p:sp>
-      <p:sp>
-        <p:nvSpPr>
-          <p:cNvPr id="6" name="Shape 4"/>
+              <a:t>BIDMAS Recap</a:t>
+            </a:r>
+            <a:endParaRPr lang="en-US" sz="2400" dirty="0"/>
+          </a:p>
+        </p:txBody>
+      </p:sp>
+      <p:sp>
+        <p:nvSpPr>
+          <p:cNvPr id="4" name="Shape 2"/>
           <p:cNvSpPr/>
           <p:nvPr/>
         </p:nvSpPr>
         <p:spPr>
           <a:xfrm>
-            <a:off x="731520" y="1051560"/>
-            <a:ext cx="7680960" cy="438912"/>
+            <a:off x="548640" y="960120"/>
+            <a:ext cx="2286000" cy="36576"/>
           </a:xfrm>
           <a:prstGeom prst="rect">
             <a:avLst/>
           </a:prstGeom>
           <a:solidFill>
-            <a:srgbClr val="FFFFFF"/>
+            <a:srgbClr val="2A9D8F"/>
           </a:solidFill>
           <a:ln/>
         </p:spPr>
       </p:sp>
       <p:sp>
         <p:nvSpPr>
-          <p:cNvPr id="7" name="Text 5"/>
+          <p:cNvPr id="5" name="Text 3"/>
           <p:cNvSpPr/>
           <p:nvPr/>
         </p:nvSpPr>
         <p:spPr>
           <a:xfrm>
-            <a:off x="868680" y="1051560"/>
-            <a:ext cx="320040" cy="438912"/>
+            <a:off x="548640" y="1188720"/>
+            <a:ext cx="10058400" cy="3474720"/>
           </a:xfrm>
           <a:prstGeom prst="rect">
             <a:avLst/>
@@ -2608,520 +2853,51 @@
           <a:ln/>
         </p:spPr>
         <p:txBody>
-          <a:bodyPr wrap="square" rtlCol="0" anchor="ctr"/>
-          <a:lstStyle/>
-          <a:p>
-            <a:pPr indent="0" marL="0">
-              <a:buNone/>
+          <a:bodyPr wrap="square" rtlCol="0" anchor="t"/>
+          <a:lstStyle/>
+          <a:p>
+            <a:pPr>
+              <a:lnSpc>
+                <a:spcPct val="150000"/>
+              </a:lnSpc>
+              <a:spcAft>
+                <a:spcPts val="600"/>
+              </a:spcAft>
             </a:pPr>
             <a:r>
-              <a:rPr lang="en-US" sz="1400" dirty="0">
-                <a:solidFill>
-                  <a:srgbClr val="2A9D8F"/>
-                </a:solidFill>
-              </a:rPr>
-              <a:t>☐</a:t>
-            </a:r>
-            <a:endParaRPr lang="en-US" sz="1400" dirty="0"/>
-          </a:p>
-        </p:txBody>
-      </p:sp>
-      <p:sp>
-        <p:nvSpPr>
-          <p:cNvPr id="8" name="Text 6"/>
-          <p:cNvSpPr/>
-          <p:nvPr/>
-        </p:nvSpPr>
-        <p:spPr>
-          <a:xfrm>
-            <a:off x="1234440" y="1051560"/>
-            <a:ext cx="6949440" cy="438912"/>
-          </a:xfrm>
-          <a:prstGeom prst="rect">
-            <a:avLst/>
-          </a:prstGeom>
-          <a:noFill/>
-          <a:ln/>
-        </p:spPr>
-        <p:txBody>
-          <a:bodyPr wrap="square" rtlCol="0" anchor="ctr"/>
-          <a:lstStyle/>
-          <a:p>
-            <a:pPr indent="0" marL="0">
-              <a:buNone/>
-            </a:pPr>
-            <a:r>
-              <a:rPr lang="en-US" sz="1300" dirty="0">
+              <a:rPr lang="en-US" sz="1500" dirty="0">
                 <a:solidFill>
                   <a:srgbClr val="3D3A36"/>
                 </a:solidFill>
-                <a:latin typeface="Calibri" pitchFamily="34" charset="0"/>
-                <a:ea typeface="Calibri" pitchFamily="34" charset="-122"/>
-                <a:cs typeface="Calibri" pitchFamily="34" charset="-120"/>
+                <a:latin typeface="Arial" pitchFamily="34" charset="0"/>
+                <a:ea typeface="Arial" pitchFamily="34" charset="-122"/>
+                <a:cs typeface="Arial" pitchFamily="34" charset="-120"/>
               </a:rPr>
-              <a:t>Place value — identify digit values, compare and order</a:t>
-            </a:r>
-            <a:endParaRPr lang="en-US" sz="1300" dirty="0"/>
-          </a:p>
-        </p:txBody>
-      </p:sp>
-      <p:sp>
-        <p:nvSpPr>
-          <p:cNvPr id="9" name="Shape 7"/>
-          <p:cNvSpPr/>
-          <p:nvPr/>
-        </p:nvSpPr>
-        <p:spPr>
-          <a:xfrm>
-            <a:off x="731520" y="1554480"/>
-            <a:ext cx="7680960" cy="438912"/>
-          </a:xfrm>
-          <a:prstGeom prst="rect">
-            <a:avLst/>
-          </a:prstGeom>
-          <a:solidFill>
-            <a:srgbClr val="F8F6F3"/>
-          </a:solidFill>
-          <a:ln/>
-        </p:spPr>
-      </p:sp>
-      <p:sp>
-        <p:nvSpPr>
-          <p:cNvPr id="10" name="Text 8"/>
-          <p:cNvSpPr/>
-          <p:nvPr/>
-        </p:nvSpPr>
-        <p:spPr>
-          <a:xfrm>
-            <a:off x="868680" y="1554480"/>
-            <a:ext cx="320040" cy="438912"/>
-          </a:xfrm>
-          <a:prstGeom prst="rect">
-            <a:avLst/>
-          </a:prstGeom>
-          <a:noFill/>
-          <a:ln/>
-        </p:spPr>
-        <p:txBody>
-          <a:bodyPr wrap="square" rtlCol="0" anchor="ctr"/>
-          <a:lstStyle/>
-          <a:p>
-            <a:pPr indent="0" marL="0">
-              <a:buNone/>
+              <a:t>Brackets → Indices → Division/Multiplication → Addition/Subtraction.</a:t>
+            </a:r>
+            <a:endParaRPr lang="en-US" sz="1500" dirty="0"/>
+          </a:p>
+          <a:p>
+            <a:pPr>
+              <a:lnSpc>
+                <a:spcPct val="150000"/>
+              </a:lnSpc>
+              <a:spcAft>
+                <a:spcPts val="600"/>
+              </a:spcAft>
             </a:pPr>
             <a:r>
-              <a:rPr lang="en-US" sz="1400" dirty="0">
-                <a:solidFill>
-                  <a:srgbClr val="2A9D8F"/>
-                </a:solidFill>
-              </a:rPr>
-              <a:t>☐</a:t>
-            </a:r>
-            <a:endParaRPr lang="en-US" sz="1400" dirty="0"/>
-          </a:p>
-        </p:txBody>
-      </p:sp>
-      <p:sp>
-        <p:nvSpPr>
-          <p:cNvPr id="11" name="Text 9"/>
-          <p:cNvSpPr/>
-          <p:nvPr/>
-        </p:nvSpPr>
-        <p:spPr>
-          <a:xfrm>
-            <a:off x="1234440" y="1554480"/>
-            <a:ext cx="6949440" cy="438912"/>
-          </a:xfrm>
-          <a:prstGeom prst="rect">
-            <a:avLst/>
-          </a:prstGeom>
-          <a:noFill/>
-          <a:ln/>
-        </p:spPr>
-        <p:txBody>
-          <a:bodyPr wrap="square" rtlCol="0" anchor="ctr"/>
-          <a:lstStyle/>
-          <a:p>
-            <a:pPr indent="0" marL="0">
-              <a:buNone/>
-            </a:pPr>
-            <a:r>
-              <a:rPr lang="en-US" sz="1300" dirty="0">
+              <a:rPr lang="en-US" sz="1500" dirty="0">
                 <a:solidFill>
                   <a:srgbClr val="3D3A36"/>
                 </a:solidFill>
-                <a:latin typeface="Calibri" pitchFamily="34" charset="0"/>
-                <a:ea typeface="Calibri" pitchFamily="34" charset="-122"/>
-                <a:cs typeface="Calibri" pitchFamily="34" charset="-120"/>
+                <a:latin typeface="Arial" pitchFamily="34" charset="0"/>
+                <a:ea typeface="Arial" pitchFamily="34" charset="-122"/>
+                <a:cs typeface="Arial" pitchFamily="34" charset="-120"/>
               </a:rPr>
-              <a:t>Rounding — to nearest 10, 100, 1000, and decimal places</a:t>
-            </a:r>
-            <a:endParaRPr lang="en-US" sz="1300" dirty="0"/>
-          </a:p>
-        </p:txBody>
-      </p:sp>
-      <p:sp>
-        <p:nvSpPr>
-          <p:cNvPr id="12" name="Shape 10"/>
-          <p:cNvSpPr/>
-          <p:nvPr/>
-        </p:nvSpPr>
-        <p:spPr>
-          <a:xfrm>
-            <a:off x="731520" y="2057400"/>
-            <a:ext cx="7680960" cy="438912"/>
-          </a:xfrm>
-          <a:prstGeom prst="rect">
-            <a:avLst/>
-          </a:prstGeom>
-          <a:solidFill>
-            <a:srgbClr val="FFFFFF"/>
-          </a:solidFill>
-          <a:ln/>
-        </p:spPr>
-      </p:sp>
-      <p:sp>
-        <p:nvSpPr>
-          <p:cNvPr id="13" name="Text 11"/>
-          <p:cNvSpPr/>
-          <p:nvPr/>
-        </p:nvSpPr>
-        <p:spPr>
-          <a:xfrm>
-            <a:off x="868680" y="2057400"/>
-            <a:ext cx="320040" cy="438912"/>
-          </a:xfrm>
-          <a:prstGeom prst="rect">
-            <a:avLst/>
-          </a:prstGeom>
-          <a:noFill/>
-          <a:ln/>
-        </p:spPr>
-        <p:txBody>
-          <a:bodyPr wrap="square" rtlCol="0" anchor="ctr"/>
-          <a:lstStyle/>
-          <a:p>
-            <a:pPr indent="0" marL="0">
-              <a:buNone/>
-            </a:pPr>
-            <a:r>
-              <a:rPr lang="en-US" sz="1400" dirty="0">
-                <a:solidFill>
-                  <a:srgbClr val="2A9D8F"/>
-                </a:solidFill>
-              </a:rPr>
-              <a:t>☐</a:t>
-            </a:r>
-            <a:endParaRPr lang="en-US" sz="1400" dirty="0"/>
-          </a:p>
-        </p:txBody>
-      </p:sp>
-      <p:sp>
-        <p:nvSpPr>
-          <p:cNvPr id="14" name="Text 12"/>
-          <p:cNvSpPr/>
-          <p:nvPr/>
-        </p:nvSpPr>
-        <p:spPr>
-          <a:xfrm>
-            <a:off x="1234440" y="2057400"/>
-            <a:ext cx="6949440" cy="438912"/>
-          </a:xfrm>
-          <a:prstGeom prst="rect">
-            <a:avLst/>
-          </a:prstGeom>
-          <a:noFill/>
-          <a:ln/>
-        </p:spPr>
-        <p:txBody>
-          <a:bodyPr wrap="square" rtlCol="0" anchor="ctr"/>
-          <a:lstStyle/>
-          <a:p>
-            <a:pPr indent="0" marL="0">
-              <a:buNone/>
-            </a:pPr>
-            <a:r>
-              <a:rPr lang="en-US" sz="1300" dirty="0">
-                <a:solidFill>
-                  <a:srgbClr val="3D3A36"/>
-                </a:solidFill>
-                <a:latin typeface="Calibri" pitchFamily="34" charset="0"/>
-                <a:ea typeface="Calibri" pitchFamily="34" charset="-122"/>
-                <a:cs typeface="Calibri" pitchFamily="34" charset="-120"/>
-              </a:rPr>
-              <a:t>BIDMAS — correct order of operations</a:t>
-            </a:r>
-            <a:endParaRPr lang="en-US" sz="1300" dirty="0"/>
-          </a:p>
-        </p:txBody>
-      </p:sp>
-      <p:sp>
-        <p:nvSpPr>
-          <p:cNvPr id="15" name="Shape 13"/>
-          <p:cNvSpPr/>
-          <p:nvPr/>
-        </p:nvSpPr>
-        <p:spPr>
-          <a:xfrm>
-            <a:off x="731520" y="2560320"/>
-            <a:ext cx="7680960" cy="438912"/>
-          </a:xfrm>
-          <a:prstGeom prst="rect">
-            <a:avLst/>
-          </a:prstGeom>
-          <a:solidFill>
-            <a:srgbClr val="F8F6F3"/>
-          </a:solidFill>
-          <a:ln/>
-        </p:spPr>
-      </p:sp>
-      <p:sp>
-        <p:nvSpPr>
-          <p:cNvPr id="16" name="Text 14"/>
-          <p:cNvSpPr/>
-          <p:nvPr/>
-        </p:nvSpPr>
-        <p:spPr>
-          <a:xfrm>
-            <a:off x="868680" y="2560320"/>
-            <a:ext cx="320040" cy="438912"/>
-          </a:xfrm>
-          <a:prstGeom prst="rect">
-            <a:avLst/>
-          </a:prstGeom>
-          <a:noFill/>
-          <a:ln/>
-        </p:spPr>
-        <p:txBody>
-          <a:bodyPr wrap="square" rtlCol="0" anchor="ctr"/>
-          <a:lstStyle/>
-          <a:p>
-            <a:pPr indent="0" marL="0">
-              <a:buNone/>
-            </a:pPr>
-            <a:r>
-              <a:rPr lang="en-US" sz="1400" dirty="0">
-                <a:solidFill>
-                  <a:srgbClr val="2A9D8F"/>
-                </a:solidFill>
-              </a:rPr>
-              <a:t>☐</a:t>
-            </a:r>
-            <a:endParaRPr lang="en-US" sz="1400" dirty="0"/>
-          </a:p>
-        </p:txBody>
-      </p:sp>
-      <p:sp>
-        <p:nvSpPr>
-          <p:cNvPr id="17" name="Text 15"/>
-          <p:cNvSpPr/>
-          <p:nvPr/>
-        </p:nvSpPr>
-        <p:spPr>
-          <a:xfrm>
-            <a:off x="1234440" y="2560320"/>
-            <a:ext cx="6949440" cy="438912"/>
-          </a:xfrm>
-          <a:prstGeom prst="rect">
-            <a:avLst/>
-          </a:prstGeom>
-          <a:noFill/>
-          <a:ln/>
-        </p:spPr>
-        <p:txBody>
-          <a:bodyPr wrap="square" rtlCol="0" anchor="ctr"/>
-          <a:lstStyle/>
-          <a:p>
-            <a:pPr indent="0" marL="0">
-              <a:buNone/>
-            </a:pPr>
-            <a:r>
-              <a:rPr lang="en-US" sz="1300" dirty="0">
-                <a:solidFill>
-                  <a:srgbClr val="3D3A36"/>
-                </a:solidFill>
-                <a:latin typeface="Calibri" pitchFamily="34" charset="0"/>
-                <a:ea typeface="Calibri" pitchFamily="34" charset="-122"/>
-                <a:cs typeface="Calibri" pitchFamily="34" charset="-120"/>
-              </a:rPr>
-              <a:t>Negative numbers — add, subtract, multiply, divide</a:t>
-            </a:r>
-            <a:endParaRPr lang="en-US" sz="1300" dirty="0"/>
-          </a:p>
-        </p:txBody>
-      </p:sp>
-      <p:sp>
-        <p:nvSpPr>
-          <p:cNvPr id="18" name="Shape 16"/>
-          <p:cNvSpPr/>
-          <p:nvPr/>
-        </p:nvSpPr>
-        <p:spPr>
-          <a:xfrm>
-            <a:off x="731520" y="3063240"/>
-            <a:ext cx="7680960" cy="438912"/>
-          </a:xfrm>
-          <a:prstGeom prst="rect">
-            <a:avLst/>
-          </a:prstGeom>
-          <a:solidFill>
-            <a:srgbClr val="FFFFFF"/>
-          </a:solidFill>
-          <a:ln/>
-        </p:spPr>
-      </p:sp>
-      <p:sp>
-        <p:nvSpPr>
-          <p:cNvPr id="19" name="Text 17"/>
-          <p:cNvSpPr/>
-          <p:nvPr/>
-        </p:nvSpPr>
-        <p:spPr>
-          <a:xfrm>
-            <a:off x="868680" y="3063240"/>
-            <a:ext cx="320040" cy="438912"/>
-          </a:xfrm>
-          <a:prstGeom prst="rect">
-            <a:avLst/>
-          </a:prstGeom>
-          <a:noFill/>
-          <a:ln/>
-        </p:spPr>
-        <p:txBody>
-          <a:bodyPr wrap="square" rtlCol="0" anchor="ctr"/>
-          <a:lstStyle/>
-          <a:p>
-            <a:pPr indent="0" marL="0">
-              <a:buNone/>
-            </a:pPr>
-            <a:r>
-              <a:rPr lang="en-US" sz="1400" dirty="0">
-                <a:solidFill>
-                  <a:srgbClr val="2A9D8F"/>
-                </a:solidFill>
-              </a:rPr>
-              <a:t>☐</a:t>
-            </a:r>
-            <a:endParaRPr lang="en-US" sz="1400" dirty="0"/>
-          </a:p>
-        </p:txBody>
-      </p:sp>
-      <p:sp>
-        <p:nvSpPr>
-          <p:cNvPr id="20" name="Text 18"/>
-          <p:cNvSpPr/>
-          <p:nvPr/>
-        </p:nvSpPr>
-        <p:spPr>
-          <a:xfrm>
-            <a:off x="1234440" y="3063240"/>
-            <a:ext cx="6949440" cy="438912"/>
-          </a:xfrm>
-          <a:prstGeom prst="rect">
-            <a:avLst/>
-          </a:prstGeom>
-          <a:noFill/>
-          <a:ln/>
-        </p:spPr>
-        <p:txBody>
-          <a:bodyPr wrap="square" rtlCol="0" anchor="ctr"/>
-          <a:lstStyle/>
-          <a:p>
-            <a:pPr indent="0" marL="0">
-              <a:buNone/>
-            </a:pPr>
-            <a:r>
-              <a:rPr lang="en-US" sz="1300" dirty="0">
-                <a:solidFill>
-                  <a:srgbClr val="3D3A36"/>
-                </a:solidFill>
-                <a:latin typeface="Calibri" pitchFamily="34" charset="0"/>
-                <a:ea typeface="Calibri" pitchFamily="34" charset="-122"/>
-                <a:cs typeface="Calibri" pitchFamily="34" charset="-120"/>
-              </a:rPr>
-              <a:t>Factors, multiples, primes, HCF, LCM</a:t>
-            </a:r>
-            <a:endParaRPr lang="en-US" sz="1300" dirty="0"/>
-          </a:p>
-        </p:txBody>
-      </p:sp>
-      <p:sp>
-        <p:nvSpPr>
-          <p:cNvPr id="21" name="Shape 19"/>
-          <p:cNvSpPr/>
-          <p:nvPr/>
-        </p:nvSpPr>
-        <p:spPr>
-          <a:xfrm>
-            <a:off x="731520" y="3749040"/>
-            <a:ext cx="7680960" cy="594360"/>
-          </a:xfrm>
-          <a:prstGeom prst="rect">
-            <a:avLst/>
-          </a:prstGeom>
-          <a:solidFill>
-            <a:srgbClr val="E8F5F3"/>
-          </a:solidFill>
-          <a:ln/>
-          <a:effectLst>
-            <a:outerShdw sx="100000" sy="100000" kx="0" ky="0" algn="bl" rotWithShape="0" blurRad="50800" dist="25400" dir="8100000">
-              <a:srgbClr val="000000">
-                <a:alpha val="10000"/>
-              </a:srgbClr>
-            </a:outerShdw>
-          </a:effectLst>
-        </p:spPr>
-      </p:sp>
-      <p:sp>
-        <p:nvSpPr>
-          <p:cNvPr id="22" name="Text 20"/>
-          <p:cNvSpPr/>
-          <p:nvPr/>
-        </p:nvSpPr>
-        <p:spPr>
-          <a:xfrm>
-            <a:off x="914400" y="3749040"/>
-            <a:ext cx="7315200" cy="594360"/>
-          </a:xfrm>
-          <a:prstGeom prst="rect">
-            <a:avLst/>
-          </a:prstGeom>
-          <a:noFill/>
-          <a:ln/>
-        </p:spPr>
-        <p:txBody>
-          <a:bodyPr wrap="square" rtlCol="0" anchor="ctr"/>
-          <a:lstStyle/>
-          <a:p>
-            <a:pPr indent="0" marL="0">
-              <a:buNone/>
-            </a:pPr>
-            <a:r>
-              <a:rPr lang="en-US" sz="1200" b="1" dirty="0">
-                <a:solidFill>
-                  <a:srgbClr val="2A9D8F"/>
-                </a:solidFill>
-                <a:latin typeface="Calibri" pitchFamily="34" charset="0"/>
-                <a:ea typeface="Calibri" pitchFamily="34" charset="-122"/>
-                <a:cs typeface="Calibri" pitchFamily="34" charset="-120"/>
-              </a:rPr>
-              <a:t>Key Idea: </a:t>
-            </a:r>
-            <a:pPr indent="0" marL="0">
-              <a:buNone/>
-            </a:pPr>
-            <a:r>
-              <a:rPr lang="en-US" sz="1200" i="1" dirty="0">
-                <a:solidFill>
-                  <a:srgbClr val="3D3A36"/>
-                </a:solidFill>
-                <a:latin typeface="Calibri" pitchFamily="34" charset="0"/>
-                <a:ea typeface="Calibri" pitchFamily="34" charset="-122"/>
-                <a:cs typeface="Calibri" pitchFamily="34" charset="-120"/>
-              </a:rPr>
-              <a:t>Test yourself with the Self-Quiz and Review Games on mrzocchi.com.</a:t>
-            </a:r>
-            <a:endParaRPr lang="en-US" sz="1200" dirty="0"/>
+              <a:t>D and M are equal (left to right). A and S are equal (left to right).</a:t>
+            </a:r>
+            <a:endParaRPr lang="en-US" sz="1500" dirty="0"/>
           </a:p>
         </p:txBody>
       </p:sp>
@@ -3133,9 +2909,16 @@
 </p:sld>
 </file>
 
-<file path=ppt/slides/slide7.xml><?xml version="1.0" encoding="utf-8"?>
+<file path=ppt/slides/slide8.xml><?xml version="1.0" encoding="utf-8"?>
 <p:sld xmlns:a="http://schemas.openxmlformats.org/drawingml/2006/main" xmlns:r="http://schemas.openxmlformats.org/officeDocument/2006/relationships" xmlns:p="http://schemas.openxmlformats.org/presentationml/2006/main">
-  <p:cSld name="Slide 7">
+  <p:cSld name="Slide 8">
+    <p:bg>
+      <p:bgPr>
+        <a:solidFill>
+          <a:srgbClr val="111D35"/>
+        </a:solidFill>
+      </p:bgPr>
+    </p:bg>
     <p:spTree>
       <p:nvGrpSpPr>
         <p:cNvPr id="1" name=""/>
@@ -3152,76 +2935,55 @@
       </p:grpSpPr>
       <p:sp>
         <p:nvSpPr>
-          <p:cNvPr id="2" name="Shape 0"/>
+          <p:cNvPr id="2" name="Text 0"/>
           <p:cNvSpPr/>
           <p:nvPr/>
         </p:nvSpPr>
         <p:spPr>
           <a:xfrm>
-            <a:off x="0" y="0"/>
-            <a:ext cx="9144000" cy="5143500"/>
-          </a:xfrm>
-          <a:prstGeom prst="rect">
-            <a:avLst/>
-          </a:prstGeom>
-          <a:solidFill>
-            <a:srgbClr val="1B2A4A"/>
-          </a:solidFill>
+            <a:off x="731520" y="731520"/>
+            <a:ext cx="2286000" cy="1828800"/>
+          </a:xfrm>
+          <a:prstGeom prst="rect">
+            <a:avLst/>
+          </a:prstGeom>
+          <a:noFill/>
           <a:ln/>
         </p:spPr>
-      </p:sp>
-      <p:sp>
-        <p:nvSpPr>
-          <p:cNvPr id="3" name="Shape 1"/>
+        <p:txBody>
+          <a:bodyPr wrap="square" rtlCol="0" anchor="ctr"/>
+          <a:lstStyle/>
+          <a:p>
+            <a:pPr indent="0" marL="0">
+              <a:buNone/>
+            </a:pPr>
+            <a:r>
+              <a:rPr lang="en-US" sz="7200" b="1" dirty="0">
+                <a:solidFill>
+                  <a:srgbClr val="2A9D8F">
+                    <a:alpha val="80000"/>
+                  </a:srgbClr>
+                </a:solidFill>
+                <a:latin typeface="Georgia" pitchFamily="34" charset="0"/>
+                <a:ea typeface="Georgia" pitchFamily="34" charset="-122"/>
+                <a:cs typeface="Georgia" pitchFamily="34" charset="-120"/>
+              </a:rPr>
+              <a:t>04</a:t>
+            </a:r>
+            <a:endParaRPr lang="en-US" sz="7200" dirty="0"/>
+          </a:p>
+        </p:txBody>
+      </p:sp>
+      <p:sp>
+        <p:nvSpPr>
+          <p:cNvPr id="3" name="Text 1"/>
           <p:cNvSpPr/>
           <p:nvPr/>
         </p:nvSpPr>
         <p:spPr>
           <a:xfrm>
-            <a:off x="0" y="4777740"/>
-            <a:ext cx="9144000" cy="365760"/>
-          </a:xfrm>
-          <a:prstGeom prst="rect">
-            <a:avLst/>
-          </a:prstGeom>
-          <a:solidFill>
-            <a:srgbClr val="2A9D8F"/>
-          </a:solidFill>
-          <a:ln/>
-        </p:spPr>
-      </p:sp>
-      <p:sp>
-        <p:nvSpPr>
-          <p:cNvPr id="4" name="Shape 2"/>
-          <p:cNvSpPr/>
-          <p:nvPr/>
-        </p:nvSpPr>
-        <p:spPr>
-          <a:xfrm>
-            <a:off x="-914400" y="-914400"/>
-            <a:ext cx="3657600" cy="3657600"/>
-          </a:xfrm>
-          <a:prstGeom prst="ellipse">
-            <a:avLst/>
-          </a:prstGeom>
-          <a:solidFill>
-            <a:srgbClr val="2A9D8F">
-              <a:alpha val="10000"/>
-            </a:srgbClr>
-          </a:solidFill>
-          <a:ln/>
-        </p:spPr>
-      </p:sp>
-      <p:sp>
-        <p:nvSpPr>
-          <p:cNvPr id="5" name="Text 3"/>
-          <p:cNvSpPr/>
-          <p:nvPr/>
-        </p:nvSpPr>
-        <p:spPr>
-          <a:xfrm>
-            <a:off x="731520" y="1463040"/>
-            <a:ext cx="7680960" cy="822960"/>
+            <a:off x="731520" y="1828800"/>
+            <a:ext cx="9144000" cy="1097280"/>
           </a:xfrm>
           <a:prstGeom prst="rect">
             <a:avLst/>
@@ -3233,11 +2995,11 @@
           <a:bodyPr wrap="square" rtlCol="0" anchor="ctr"/>
           <a:lstStyle/>
           <a:p>
-            <a:pPr algn="ctr" indent="0" marL="0">
+            <a:pPr indent="0" marL="0">
               <a:buNone/>
             </a:pPr>
             <a:r>
-              <a:rPr lang="en-US" sz="3400" b="1" dirty="0">
+              <a:rPr lang="en-US" sz="3200" b="1" dirty="0">
                 <a:solidFill>
                   <a:srgbClr val="FFFFFF"/>
                 </a:solidFill>
@@ -3245,22 +3007,74 @@
                 <a:ea typeface="Georgia" pitchFamily="34" charset="-122"/>
                 <a:cs typeface="Georgia" pitchFamily="34" charset="-120"/>
               </a:rPr>
-              <a:t>Review &amp; Practise</a:t>
-            </a:r>
-            <a:endParaRPr lang="en-US" sz="3400" dirty="0"/>
-          </a:p>
-        </p:txBody>
-      </p:sp>
-      <p:sp>
-        <p:nvSpPr>
-          <p:cNvPr id="6" name="Text 4"/>
+              <a:t>Negative Numbers &amp; Factors</a:t>
+            </a:r>
+            <a:endParaRPr lang="en-US" sz="3200" dirty="0"/>
+          </a:p>
+        </p:txBody>
+      </p:sp>
+    </p:spTree>
+  </p:cSld>
+  <p:clrMapOvr>
+    <a:masterClrMapping/>
+  </p:clrMapOvr>
+</p:sld>
+</file>
+
+<file path=ppt/slides/slide9.xml><?xml version="1.0" encoding="utf-8"?>
+<p:sld xmlns:a="http://schemas.openxmlformats.org/drawingml/2006/main" xmlns:r="http://schemas.openxmlformats.org/officeDocument/2006/relationships" xmlns:p="http://schemas.openxmlformats.org/presentationml/2006/main">
+  <p:cSld name="Slide 9">
+    <p:bg>
+      <p:bgPr>
+        <a:solidFill>
+          <a:srgbClr val="FAF8F5"/>
+        </a:solidFill>
+      </p:bgPr>
+    </p:bg>
+    <p:spTree>
+      <p:nvGrpSpPr>
+        <p:cNvPr id="1" name=""/>
+        <p:cNvGrpSpPr/>
+        <p:nvPr/>
+      </p:nvGrpSpPr>
+      <p:grpSpPr>
+        <a:xfrm>
+          <a:off x="0" y="0"/>
+          <a:ext cx="0" cy="0"/>
+          <a:chOff x="0" y="0"/>
+          <a:chExt cx="0" cy="0"/>
+        </a:xfrm>
+      </p:grpSpPr>
+      <p:sp>
+        <p:nvSpPr>
+          <p:cNvPr id="2" name="Shape 0"/>
           <p:cNvSpPr/>
           <p:nvPr/>
         </p:nvSpPr>
         <p:spPr>
           <a:xfrm>
-            <a:off x="731520" y="2468880"/>
-            <a:ext cx="7680960" cy="457200"/>
+            <a:off x="0" y="0"/>
+            <a:ext cx="73152" cy="5148072"/>
+          </a:xfrm>
+          <a:prstGeom prst="rect">
+            <a:avLst/>
+          </a:prstGeom>
+          <a:solidFill>
+            <a:srgbClr val="2A9D8F"/>
+          </a:solidFill>
+          <a:ln/>
+        </p:spPr>
+      </p:sp>
+      <p:sp>
+        <p:nvSpPr>
+          <p:cNvPr id="3" name="Text 1"/>
+          <p:cNvSpPr/>
+          <p:nvPr/>
+        </p:nvSpPr>
+        <p:spPr>
+          <a:xfrm>
+            <a:off x="548640" y="274320"/>
+            <a:ext cx="9144000" cy="640080"/>
           </a:xfrm>
           <a:prstGeom prst="rect">
             <a:avLst/>
@@ -3272,34 +3086,54 @@
           <a:bodyPr wrap="square" rtlCol="0" anchor="ctr"/>
           <a:lstStyle/>
           <a:p>
-            <a:pPr algn="ctr" indent="0" marL="0">
+            <a:pPr indent="0" marL="0">
               <a:buNone/>
             </a:pPr>
             <a:r>
-              <a:rPr lang="en-US" sz="1800" dirty="0">
+              <a:rPr lang="en-US" sz="2400" b="1" dirty="0">
                 <a:solidFill>
-                  <a:srgbClr val="2A9D8F"/>
+                  <a:srgbClr val="1B2A4A"/>
                 </a:solidFill>
-                <a:latin typeface="Calibri" pitchFamily="34" charset="0"/>
-                <a:ea typeface="Calibri" pitchFamily="34" charset="-122"/>
-                <a:cs typeface="Calibri" pitchFamily="34" charset="-120"/>
+                <a:latin typeface="Georgia" pitchFamily="34" charset="0"/>
+                <a:ea typeface="Georgia" pitchFamily="34" charset="-122"/>
+                <a:cs typeface="Georgia" pitchFamily="34" charset="-120"/>
               </a:rPr>
-              <a:t>mrzocchi.com</a:t>
-            </a:r>
-            <a:endParaRPr lang="en-US" sz="1800" dirty="0"/>
-          </a:p>
-        </p:txBody>
-      </p:sp>
-      <p:sp>
-        <p:nvSpPr>
-          <p:cNvPr id="7" name="Text 5"/>
+              <a:t>Negatives &amp; Factors Recap</a:t>
+            </a:r>
+            <a:endParaRPr lang="en-US" sz="2400" dirty="0"/>
+          </a:p>
+        </p:txBody>
+      </p:sp>
+      <p:sp>
+        <p:nvSpPr>
+          <p:cNvPr id="4" name="Shape 2"/>
           <p:cNvSpPr/>
           <p:nvPr/>
         </p:nvSpPr>
         <p:spPr>
           <a:xfrm>
-            <a:off x="731520" y="3108960"/>
-            <a:ext cx="7680960" cy="457200"/>
+            <a:off x="548640" y="960120"/>
+            <a:ext cx="2286000" cy="36576"/>
+          </a:xfrm>
+          <a:prstGeom prst="rect">
+            <a:avLst/>
+          </a:prstGeom>
+          <a:solidFill>
+            <a:srgbClr val="2A9D8F"/>
+          </a:solidFill>
+          <a:ln/>
+        </p:spPr>
+      </p:sp>
+      <p:sp>
+        <p:nvSpPr>
+          <p:cNvPr id="5" name="Text 3"/>
+          <p:cNvSpPr/>
+          <p:nvPr/>
+        </p:nvSpPr>
+        <p:spPr>
+          <a:xfrm>
+            <a:off x="548640" y="1188720"/>
+            <a:ext cx="10058400" cy="3474720"/>
           </a:xfrm>
           <a:prstGeom prst="rect">
             <a:avLst/>
@@ -3308,24 +3142,51 @@
           <a:ln/>
         </p:spPr>
         <p:txBody>
-          <a:bodyPr wrap="square" rtlCol="0" anchor="ctr"/>
-          <a:lstStyle/>
-          <a:p>
-            <a:pPr algn="ctr" indent="0" marL="0">
-              <a:buNone/>
+          <a:bodyPr wrap="square" rtlCol="0" anchor="t"/>
+          <a:lstStyle/>
+          <a:p>
+            <a:pPr>
+              <a:lnSpc>
+                <a:spcPct val="150000"/>
+              </a:lnSpc>
+              <a:spcAft>
+                <a:spcPts val="600"/>
+              </a:spcAft>
             </a:pPr>
             <a:r>
-              <a:rPr lang="en-US" sz="1300" dirty="0">
+              <a:rPr lang="en-US" sz="1500" dirty="0">
                 <a:solidFill>
-                  <a:srgbClr val="9B9690"/>
+                  <a:srgbClr val="3D3A36"/>
                 </a:solidFill>
-                <a:latin typeface="Calibri" pitchFamily="34" charset="0"/>
-                <a:ea typeface="Calibri" pitchFamily="34" charset="-122"/>
-                <a:cs typeface="Calibri" pitchFamily="34" charset="-120"/>
+                <a:latin typeface="Arial" pitchFamily="34" charset="0"/>
+                <a:ea typeface="Arial" pitchFamily="34" charset="-122"/>
+                <a:cs typeface="Arial" pitchFamily="34" charset="-120"/>
               </a:rPr>
-              <a:t>Use the Self-Quiz, Review Games, and Practice Builder to test yourself.</a:t>
-            </a:r>
-            <a:endParaRPr lang="en-US" sz="1300" dirty="0"/>
+              <a:t>Negative numbers: further left = smaller. Subtracting a negative = adding.</a:t>
+            </a:r>
+            <a:endParaRPr lang="en-US" sz="1500" dirty="0"/>
+          </a:p>
+          <a:p>
+            <a:pPr>
+              <a:lnSpc>
+                <a:spcPct val="150000"/>
+              </a:lnSpc>
+              <a:spcAft>
+                <a:spcPts val="600"/>
+              </a:spcAft>
+            </a:pPr>
+            <a:r>
+              <a:rPr lang="en-US" sz="1500" dirty="0">
+                <a:solidFill>
+                  <a:srgbClr val="3D3A36"/>
+                </a:solidFill>
+                <a:latin typeface="Arial" pitchFamily="34" charset="0"/>
+                <a:ea typeface="Arial" pitchFamily="34" charset="-122"/>
+                <a:cs typeface="Arial" pitchFamily="34" charset="-120"/>
+              </a:rPr>
+              <a:t>Factors: divide exactly. Multiples: times table results. Primes: exactly 2 factors.</a:t>
+            </a:r>
+            <a:endParaRPr lang="en-US" sz="1500" dirty="0"/>
           </a:p>
         </p:txBody>
       </p:sp>

</xml_diff>